<commit_message>
docs: update ClassPilot product presentation
</commit_message>
<xml_diff>
--- a/product-presentation/ClassPilot-AI-Product-Introduction.pptx
+++ b/product-presentation/ClassPilot-AI-Product-Introduction.pptx
@@ -2,21 +2,21 @@
 <file path=ppt/presentation.xml><?xml version="1.0" encoding="utf-8"?>
 <p:presentation xmlns:p="http://schemas.openxmlformats.org/presentationml/2006/main">
   <p:sldMasterIdLst>
-    <p:sldMasterId xmlns:r="http://schemas.openxmlformats.org/officeDocument/2006/relationships" id="2147483648" r:id="R6bba25dc900c48d2"/>
+    <p:sldMasterId xmlns:r="http://schemas.openxmlformats.org/officeDocument/2006/relationships" id="2147483648" r:id="R43dc006ba7914c27"/>
   </p:sldMasterIdLst>
   <p:notesMasterIdLst>
-    <p:notesMasterId xmlns:r="http://schemas.openxmlformats.org/officeDocument/2006/relationships" r:id="Rf5bea1f3331745a1"/>
+    <p:notesMasterId xmlns:r="http://schemas.openxmlformats.org/officeDocument/2006/relationships" r:id="Ra4b9cefdc6064f7f"/>
   </p:notesMasterIdLst>
   <p:sldIdLst>
-    <p:sldId xmlns:r="http://schemas.openxmlformats.org/officeDocument/2006/relationships" id="256" r:id="Rc0d73fd047734cd6"/>
-    <p:sldId xmlns:r="http://schemas.openxmlformats.org/officeDocument/2006/relationships" id="257" r:id="R0c09c5d59c8c4b6c"/>
-    <p:sldId xmlns:r="http://schemas.openxmlformats.org/officeDocument/2006/relationships" id="258" r:id="R800e55b8bc644bb9"/>
-    <p:sldId xmlns:r="http://schemas.openxmlformats.org/officeDocument/2006/relationships" id="259" r:id="Rd67132c2ebdb4dd4"/>
-    <p:sldId xmlns:r="http://schemas.openxmlformats.org/officeDocument/2006/relationships" id="260" r:id="Rbf7e1ad497fe4ce6"/>
-    <p:sldId xmlns:r="http://schemas.openxmlformats.org/officeDocument/2006/relationships" id="261" r:id="R448f7d096f16475b"/>
-    <p:sldId xmlns:r="http://schemas.openxmlformats.org/officeDocument/2006/relationships" id="262" r:id="R7f3551a379a14393"/>
-    <p:sldId xmlns:r="http://schemas.openxmlformats.org/officeDocument/2006/relationships" id="263" r:id="R535bbd9bfce643c5"/>
-    <p:sldId xmlns:r="http://schemas.openxmlformats.org/officeDocument/2006/relationships" id="264" r:id="Rb415f9de078543ae"/>
+    <p:sldId xmlns:r="http://schemas.openxmlformats.org/officeDocument/2006/relationships" id="256" r:id="Rd49fc55df65449c4"/>
+    <p:sldId xmlns:r="http://schemas.openxmlformats.org/officeDocument/2006/relationships" id="257" r:id="Ra88ebe294b824b64"/>
+    <p:sldId xmlns:r="http://schemas.openxmlformats.org/officeDocument/2006/relationships" id="258" r:id="Rc0e2663f12874896"/>
+    <p:sldId xmlns:r="http://schemas.openxmlformats.org/officeDocument/2006/relationships" id="259" r:id="R2874afd358e04081"/>
+    <p:sldId xmlns:r="http://schemas.openxmlformats.org/officeDocument/2006/relationships" id="260" r:id="R9533f6656fdb4f55"/>
+    <p:sldId xmlns:r="http://schemas.openxmlformats.org/officeDocument/2006/relationships" id="261" r:id="Ra7c0434d8d924364"/>
+    <p:sldId xmlns:r="http://schemas.openxmlformats.org/officeDocument/2006/relationships" id="262" r:id="R9b529e60e68c4312"/>
+    <p:sldId xmlns:r="http://schemas.openxmlformats.org/officeDocument/2006/relationships" id="263" r:id="Rb62c406f6b6e4cea"/>
+    <p:sldId xmlns:r="http://schemas.openxmlformats.org/officeDocument/2006/relationships" id="264" r:id="R3606e903a8174f14"/>
   </p:sldIdLst>
   <p:sldSz cx="12192000" cy="6858000"/>
   <p:notesSz cx="6858000" cy="9144000"/>
@@ -810,7 +810,7 @@
           <a:lstStyle xmlns:a="http://schemas.openxmlformats.org/drawingml/2006/main"/>
           <a:p xmlns:a="http://schemas.openxmlformats.org/drawingml/2006/main">
             <a:r>
-              <a:t>Show the two-turn live conversation. The Coach first identifies the easiest-to-miss requirement, then converts that advice into a three-day plan with evidence citations and actionable steps.</a:t>
+              <a:t>Show the live one-step loop. The Coach reads the selected assignment, gives one small action, asks one checkpoint question, and waits for the student before adapting.</a:t>
             </a:r>
           </a:p>
           <a:p xmlns:a="http://schemas.openxmlformats.org/drawingml/2006/main">
@@ -825,7 +825,7 @@
           </a:p>
           <a:p xmlns:a="http://schemas.openxmlformats.org/drawingml/2006/main">
             <a:r>
-              <a:t>- ClassPilot AI live product screenshot and Workers AI response, captured July 25, 2026.</a:t>
+              <a:t>- ClassPilot AI live product screenshot and Workers AI response, captured July 27, 2026.</a:t>
             </a:r>
           </a:p>
           <a:p xmlns:a="http://schemas.openxmlformats.org/drawingml/2006/main">
@@ -900,7 +900,7 @@
           <a:lstStyle xmlns:a="http://schemas.openxmlformats.org/drawingml/2006/main"/>
           <a:p xmlns:a="http://schemas.openxmlformats.org/drawingml/2006/main">
             <a:r>
-              <a:t>Explain how ClassPilot supports execution, not only import. Be transparent that the Canvas OAuth flow is implemented but institutional approval is an external prerequisite.</a:t>
+              <a:t>Explain how ClassPilot supports execution, not only import. Students without institutional API access can use a local calendar feed or explicitly capture the Canvas page they are viewing.</a:t>
             </a:r>
           </a:p>
           <a:p xmlns:a="http://schemas.openxmlformats.org/drawingml/2006/main">
@@ -915,12 +915,12 @@
           </a:p>
           <a:p xmlns:a="http://schemas.openxmlformats.org/drawingml/2006/main">
             <a:r>
-              <a:t>- ClassPilot AI Today, study scheduler, submission checker, and Canvas connector implementations, July 2026.</a:t>
-            </a:r>
-          </a:p>
-          <a:p xmlns:a="http://schemas.openxmlformats.org/drawingml/2006/main">
-            <a:r>
-              <a:t>- Canvas LMS OAuth2 documentation: https://developerdocs.instructure.com/services/canvas/oauth2</a:t>
+              <a:t>- ClassPilot AI Today, study scheduler, submission checker, Canvas calendar feed, and Canvas Companion implementations, July 2026.</a:t>
+            </a:r>
+          </a:p>
+          <a:p xmlns:a="http://schemas.openxmlformats.org/drawingml/2006/main">
+            <a:r>
+              <a:t>- Canvas calendar feed documentation: https://community.canvaslms.com/t5/Student-Guide/How-do-I-view-the-Calendar-iCal-feed/ta-p/1806</a:t>
             </a:r>
           </a:p>
           <a:p xmlns:a="http://schemas.openxmlformats.org/drawingml/2006/main">
@@ -995,7 +995,7 @@
           <a:lstStyle xmlns:a="http://schemas.openxmlformats.org/drawingml/2006/main"/>
           <a:p xmlns:a="http://schemas.openxmlformats.org/drawingml/2006/main">
             <a:r>
-              <a:t>Use this slide to explain the privacy and academic-integrity boundary. Workers AI is the default live provider; an OpenAI server-side provider remains optional without changing the public response contract.</a:t>
+              <a:t>Use this slide to explain the privacy and academic-integrity boundary. The Worker validates every response and recovers a useful model-generated action when the model places it in the wrong field.</a:t>
             </a:r>
           </a:p>
           <a:p xmlns:a="http://schemas.openxmlformats.org/drawingml/2006/main">
@@ -1010,7 +1010,7 @@
           </a:p>
           <a:p xmlns:a="http://schemas.openxmlformats.org/drawingml/2006/main">
             <a:r>
-              <a:t>- ClassPilot AI Worker and Coach system instructions, July 25, 2026.</a:t>
+              <a:t>- ClassPilot AI Worker and Coach response contract, July 27, 2026.</a:t>
             </a:r>
           </a:p>
           <a:p xmlns:a="http://schemas.openxmlformats.org/drawingml/2006/main">
@@ -1095,7 +1095,7 @@
           <a:lstStyle xmlns:a="http://schemas.openxmlformats.org/drawingml/2006/main"/>
           <a:p xmlns:a="http://schemas.openxmlformats.org/drawingml/2006/main">
             <a:r>
-              <a:t>Share the verification evidence: 326 automated tests passed, the public product had no browser console errors, and the 390-pixel mobile layout had no page or transcript overflow.</a:t>
+              <a:t>Share the verification evidence: 365 automated tests passed, the public product had no Coach error, and the 390-pixel mobile layout had no horizontal overflow with exactly one interactive step.</a:t>
             </a:r>
           </a:p>
           <a:p xmlns:a="http://schemas.openxmlformats.org/drawingml/2006/main">
@@ -1110,12 +1110,12 @@
           </a:p>
           <a:p xmlns:a="http://schemas.openxmlformats.org/drawingml/2006/main">
             <a:r>
-              <a:t>- ClassPilot AI test suite and public browser QA, July 25, 2026.</a:t>
-            </a:r>
-          </a:p>
-          <a:p xmlns:a="http://schemas.openxmlformats.org/drawingml/2006/main">
-            <a:r>
-              <a:t>- ClassPilot AI live mobile product screenshot, captured July 25, 2026.</a:t>
+              <a:t>- ClassPilot AI test suite and public browser QA, July 27, 2026.</a:t>
+            </a:r>
+          </a:p>
+          <a:p xmlns:a="http://schemas.openxmlformats.org/drawingml/2006/main">
+            <a:r>
+              <a:t>- ClassPilot AI live mobile product screenshot, captured July 27, 2026.</a:t>
             </a:r>
           </a:p>
           <a:p xmlns:a="http://schemas.openxmlformats.org/drawingml/2006/main">
@@ -1190,7 +1190,7 @@
           <a:lstStyle xmlns:a="http://schemas.openxmlformats.org/drawingml/2006/main"/>
           <a:p xmlns:a="http://schemas.openxmlformats.org/drawingml/2006/main">
             <a:r>
-              <a:t>Close on the product promise and open the live URL. The Coach is online through Workers AI; Canvas sync will become active after the school approves a Developer Key.</a:t>
+              <a:t>Close on the product promise and open the live URL. The Coach is online through Workers AI, while Canvas calendar feed and Companion imports work without a Developer Key.</a:t>
             </a:r>
           </a:p>
           <a:p xmlns:a="http://schemas.openxmlformats.org/drawingml/2006/main">
@@ -1283,7 +1283,7 @@
   </p:cSld>
   <p:clrMap bg1="lt1" tx1="dk1" bg2="lt2" tx2="dk2" accent1="accent1" accent2="accent2" accent3="accent3" accent4="accent4" accent5="accent5" accent6="accent6" hlink="hlink" folHlink="folHlink"/>
   <p:sldLayoutIdLst>
-    <p:sldLayoutId xmlns:r="http://schemas.openxmlformats.org/officeDocument/2006/relationships" id="2147483649" r:id="R5627ecae792f435f"/>
+    <p:sldLayoutId xmlns:r="http://schemas.openxmlformats.org/officeDocument/2006/relationships" id="2147483649" r:id="R2c0ddd83bcec4b3b"/>
   </p:sldLayoutIdLst>
   <p:txStyles>
     <p:titleStyle>
@@ -1834,7 +1834,7 @@
           <p:cNvPr id="8" name="cover-accent">
             <a:extLst xmlns:a="http://schemas.openxmlformats.org/drawingml/2006/main">
               <a:ext uri="{FF2B5EF4-FFF2-40B4-BE49-F238E27FC236}">
-                <a16:creationId xmlns:a16="http://schemas.microsoft.com/office/drawing/2014/main" id="{DDCC0067-4EED-49E1-B814-F62D9EA49F84}"/>
+                <a16:creationId xmlns:a16="http://schemas.microsoft.com/office/drawing/2014/main" id="{35B2A1B7-1794-491A-9B68-60CCE2A8339A}"/>
               </a:ext>
             </a:extLst>
           </p:cNvPr>
@@ -1867,7 +1867,7 @@
           <p:cNvPr id="2" name="cover-kicker">
             <a:extLst xmlns:a="http://schemas.openxmlformats.org/drawingml/2006/main">
               <a:ext uri="{FF2B5EF4-FFF2-40B4-BE49-F238E27FC236}">
-                <a16:creationId xmlns:a16="http://schemas.microsoft.com/office/drawing/2014/main" id="{015AE949-3195-4FCD-B75D-43D6EEDE0F6C}"/>
+                <a16:creationId xmlns:a16="http://schemas.microsoft.com/office/drawing/2014/main" id="{1451072C-5C7D-4BC0-835A-943AAA3132B4}"/>
               </a:ext>
             </a:extLst>
           </p:cNvPr>
@@ -1917,7 +1917,7 @@
           <p:cNvPr id="3" name="cover-title">
             <a:extLst xmlns:a="http://schemas.openxmlformats.org/drawingml/2006/main">
               <a:ext uri="{FF2B5EF4-FFF2-40B4-BE49-F238E27FC236}">
-                <a16:creationId xmlns:a16="http://schemas.microsoft.com/office/drawing/2014/main" id="{D58A0D3F-5EDE-4086-AC33-0C6A4982D70B}"/>
+                <a16:creationId xmlns:a16="http://schemas.microsoft.com/office/drawing/2014/main" id="{D130C052-C1A2-4095-ADEE-FA54F66ABDA4}"/>
               </a:ext>
             </a:extLst>
           </p:cNvPr>
@@ -1984,7 +1984,7 @@
           <p:cNvPr id="4" name="cover-body">
             <a:extLst xmlns:a="http://schemas.openxmlformats.org/drawingml/2006/main">
               <a:ext uri="{FF2B5EF4-FFF2-40B4-BE49-F238E27FC236}">
-                <a16:creationId xmlns:a16="http://schemas.microsoft.com/office/drawing/2014/main" id="{210CA153-8888-415B-95A2-C3DC988FA63E}"/>
+                <a16:creationId xmlns:a16="http://schemas.microsoft.com/office/drawing/2014/main" id="{246B2E2C-D230-4AA5-91BE-1FFA5B396619}"/>
               </a:ext>
             </a:extLst>
           </p:cNvPr>
@@ -2034,7 +2034,7 @@
           <p:cNvPr id="5" name="label-Product introduction-62">
             <a:extLst xmlns:a="http://schemas.openxmlformats.org/drawingml/2006/main">
               <a:ext uri="{FF2B5EF4-FFF2-40B4-BE49-F238E27FC236}">
-                <a16:creationId xmlns:a16="http://schemas.microsoft.com/office/drawing/2014/main" id="{1229FEA3-7838-4C52-8910-9A820B9C2CBF}"/>
+                <a16:creationId xmlns:a16="http://schemas.microsoft.com/office/drawing/2014/main" id="{FC1D486C-CF37-4216-BAA4-4EB06D15717B}"/>
               </a:ext>
             </a:extLst>
           </p:cNvPr>
@@ -2090,7 +2090,7 @@
           <p:cNvPr id="6" name="cover-screen-frame">
             <a:extLst xmlns:a="http://schemas.openxmlformats.org/drawingml/2006/main">
               <a:ext uri="{FF2B5EF4-FFF2-40B4-BE49-F238E27FC236}">
-                <a16:creationId xmlns:a16="http://schemas.microsoft.com/office/drawing/2014/main" id="{3E3B973C-9308-4886-A6BD-349EEA6125FD}"/>
+                <a16:creationId xmlns:a16="http://schemas.microsoft.com/office/drawing/2014/main" id="{5A0FB9B5-DF0A-4E52-AF08-D9CE9835C6EE}"/>
               </a:ext>
             </a:extLst>
           </p:cNvPr>
@@ -2129,8 +2129,8 @@
           <p:nvPr/>
         </p:nvPicPr>
         <p:blipFill>
-          <a:blip xmlns:r="http://schemas.openxmlformats.org/officeDocument/2006/relationships" xmlns:a="http://schemas.openxmlformats.org/drawingml/2006/main" r:embed="Rf0499b74358b400c"/>
-          <a:srcRect xmlns:a="http://schemas.openxmlformats.org/drawingml/2006/main" l="2017" t="0" r="2017" b="0"/>
+          <a:blip xmlns:r="http://schemas.openxmlformats.org/officeDocument/2006/relationships" xmlns:a="http://schemas.openxmlformats.org/drawingml/2006/main" r:embed="R5b803a7c418049e0"/>
+          <a:srcRect xmlns:a="http://schemas.openxmlformats.org/drawingml/2006/main" l="15942" t="0" r="15942" b="0"/>
           <a:stretch xmlns:a="http://schemas.openxmlformats.org/drawingml/2006/main">
             <a:fillRect l="0" t="0" r="0" b="0"/>
           </a:stretch>
@@ -2150,7 +2150,7 @@
     </p:spTree>
     <p:extLst>
       <p:ext uri="{BB962C8B-B14F-4D97-AF65-F5344CB8AC3E}">
-        <p14:creationId xmlns:p14="http://schemas.microsoft.com/office/powerpoint/2010/main" val="797015344"/>
+        <p14:creationId xmlns:p14="http://schemas.microsoft.com/office/powerpoint/2010/main" val="1735593376"/>
       </p:ext>
     </p:extLst>
   </p:cSld>
@@ -2181,7 +2181,7 @@
           <p:cNvPr id="18" name="section-2">
             <a:extLst xmlns:a="http://schemas.openxmlformats.org/drawingml/2006/main">
               <a:ext uri="{FF2B5EF4-FFF2-40B4-BE49-F238E27FC236}">
-                <a16:creationId xmlns:a16="http://schemas.microsoft.com/office/drawing/2014/main" id="{6CC7964F-EF1A-421F-B39E-EA6981A08DD6}"/>
+                <a16:creationId xmlns:a16="http://schemas.microsoft.com/office/drawing/2014/main" id="{E1BE0053-277A-431F-A450-BA8B7B00E50E}"/>
               </a:ext>
             </a:extLst>
           </p:cNvPr>
@@ -2231,7 +2231,7 @@
           <p:cNvPr id="2" name="page-2">
             <a:extLst xmlns:a="http://schemas.openxmlformats.org/drawingml/2006/main">
               <a:ext uri="{FF2B5EF4-FFF2-40B4-BE49-F238E27FC236}">
-                <a16:creationId xmlns:a16="http://schemas.microsoft.com/office/drawing/2014/main" id="{E6E8A8DB-074D-4F4A-9213-5CB1EAC7A660}"/>
+                <a16:creationId xmlns:a16="http://schemas.microsoft.com/office/drawing/2014/main" id="{B2CD36A9-8DF0-4A2D-93BA-0E11E00974B4}"/>
               </a:ext>
             </a:extLst>
           </p:cNvPr>
@@ -2281,7 +2281,7 @@
           <p:cNvPr id="3" name="rule-48-66">
             <a:extLst xmlns:a="http://schemas.openxmlformats.org/drawingml/2006/main">
               <a:ext uri="{FF2B5EF4-FFF2-40B4-BE49-F238E27FC236}">
-                <a16:creationId xmlns:a16="http://schemas.microsoft.com/office/drawing/2014/main" id="{EBA05033-4F05-43BA-BBAF-73BC5053FEA1}"/>
+                <a16:creationId xmlns:a16="http://schemas.microsoft.com/office/drawing/2014/main" id="{9C4C3F5D-B6B8-4482-B1C7-7749AF73349A}"/>
               </a:ext>
             </a:extLst>
           </p:cNvPr>
@@ -2312,7 +2312,7 @@
           <p:cNvPr id="4" name="title-Students do not need another dashboard.">
             <a:extLst xmlns:a="http://schemas.openxmlformats.org/drawingml/2006/main">
               <a:ext uri="{FF2B5EF4-FFF2-40B4-BE49-F238E27FC236}">
-                <a16:creationId xmlns:a16="http://schemas.microsoft.com/office/drawing/2014/main" id="{45718F58-F3C7-47BB-A2DA-61AFB4D94128}"/>
+                <a16:creationId xmlns:a16="http://schemas.microsoft.com/office/drawing/2014/main" id="{13923A4E-4CBB-4A9D-9223-1620CD93E7D2}"/>
               </a:ext>
             </a:extLst>
           </p:cNvPr>
@@ -2362,7 +2362,7 @@
           <p:cNvPr id="5" name="subtitle-Students do not need another dashboard.">
             <a:extLst xmlns:a="http://schemas.openxmlformats.org/drawingml/2006/main">
               <a:ext uri="{FF2B5EF4-FFF2-40B4-BE49-F238E27FC236}">
-                <a16:creationId xmlns:a16="http://schemas.microsoft.com/office/drawing/2014/main" id="{AAB437CA-9BF1-42A4-88EF-CE7A01BDF9C5}"/>
+                <a16:creationId xmlns:a16="http://schemas.microsoft.com/office/drawing/2014/main" id="{B91BBF21-5074-4B65-9152-183DBCA391C6}"/>
               </a:ext>
             </a:extLst>
           </p:cNvPr>
@@ -2412,7 +2412,7 @@
           <p:cNvPr id="6" name="problem-card-0">
             <a:extLst xmlns:a="http://schemas.openxmlformats.org/drawingml/2006/main">
               <a:ext uri="{FF2B5EF4-FFF2-40B4-BE49-F238E27FC236}">
-                <a16:creationId xmlns:a16="http://schemas.microsoft.com/office/drawing/2014/main" id="{1CC18705-A946-49D7-8D56-B0BE6FD0FD6E}"/>
+                <a16:creationId xmlns:a16="http://schemas.microsoft.com/office/drawing/2014/main" id="{48D153AE-D0B0-44D1-B547-C0B6CACD6AA2}"/>
               </a:ext>
             </a:extLst>
           </p:cNvPr>
@@ -2447,7 +2447,7 @@
           <p:cNvPr id="7" name="problem-number-0">
             <a:extLst xmlns:a="http://schemas.openxmlformats.org/drawingml/2006/main">
               <a:ext uri="{FF2B5EF4-FFF2-40B4-BE49-F238E27FC236}">
-                <a16:creationId xmlns:a16="http://schemas.microsoft.com/office/drawing/2014/main" id="{C42C15EC-DD2D-4BAA-9098-856539CF1C1E}"/>
+                <a16:creationId xmlns:a16="http://schemas.microsoft.com/office/drawing/2014/main" id="{E9202568-EF88-47B3-979F-992F061FC5FB}"/>
               </a:ext>
             </a:extLst>
           </p:cNvPr>
@@ -2497,7 +2497,7 @@
           <p:cNvPr id="8" name="problem-title-0">
             <a:extLst xmlns:a="http://schemas.openxmlformats.org/drawingml/2006/main">
               <a:ext uri="{FF2B5EF4-FFF2-40B4-BE49-F238E27FC236}">
-                <a16:creationId xmlns:a16="http://schemas.microsoft.com/office/drawing/2014/main" id="{A12300B3-41F6-46E6-A8CF-E13BF62DDD38}"/>
+                <a16:creationId xmlns:a16="http://schemas.microsoft.com/office/drawing/2014/main" id="{96B8A65A-D9B7-4B1B-95EB-2E74F3F247C5}"/>
               </a:ext>
             </a:extLst>
           </p:cNvPr>
@@ -2547,7 +2547,7 @@
           <p:cNvPr id="9" name="problem-body-0">
             <a:extLst xmlns:a="http://schemas.openxmlformats.org/drawingml/2006/main">
               <a:ext uri="{FF2B5EF4-FFF2-40B4-BE49-F238E27FC236}">
-                <a16:creationId xmlns:a16="http://schemas.microsoft.com/office/drawing/2014/main" id="{6F2EC913-EA92-4E7A-B582-7A77AD2AE3EE}"/>
+                <a16:creationId xmlns:a16="http://schemas.microsoft.com/office/drawing/2014/main" id="{A8D946A4-C66D-41E4-A402-522F87B07841}"/>
               </a:ext>
             </a:extLst>
           </p:cNvPr>
@@ -2597,7 +2597,7 @@
           <p:cNvPr id="10" name="problem-card-1">
             <a:extLst xmlns:a="http://schemas.openxmlformats.org/drawingml/2006/main">
               <a:ext uri="{FF2B5EF4-FFF2-40B4-BE49-F238E27FC236}">
-                <a16:creationId xmlns:a16="http://schemas.microsoft.com/office/drawing/2014/main" id="{57B3C753-52B9-40DE-81F6-871748B5AE1C}"/>
+                <a16:creationId xmlns:a16="http://schemas.microsoft.com/office/drawing/2014/main" id="{A5385C68-25D4-4D6D-B692-A5D20EC4D3B2}"/>
               </a:ext>
             </a:extLst>
           </p:cNvPr>
@@ -2632,7 +2632,7 @@
           <p:cNvPr id="11" name="problem-number-1">
             <a:extLst xmlns:a="http://schemas.openxmlformats.org/drawingml/2006/main">
               <a:ext uri="{FF2B5EF4-FFF2-40B4-BE49-F238E27FC236}">
-                <a16:creationId xmlns:a16="http://schemas.microsoft.com/office/drawing/2014/main" id="{75D072BC-6878-43E9-A9EB-5DB960ABBAEE}"/>
+                <a16:creationId xmlns:a16="http://schemas.microsoft.com/office/drawing/2014/main" id="{A6A25C92-EA96-4581-95F3-A99498C29598}"/>
               </a:ext>
             </a:extLst>
           </p:cNvPr>
@@ -2682,7 +2682,7 @@
           <p:cNvPr id="12" name="problem-title-1">
             <a:extLst xmlns:a="http://schemas.openxmlformats.org/drawingml/2006/main">
               <a:ext uri="{FF2B5EF4-FFF2-40B4-BE49-F238E27FC236}">
-                <a16:creationId xmlns:a16="http://schemas.microsoft.com/office/drawing/2014/main" id="{0E2AFD70-05A2-48A4-B070-89BBE701B2CE}"/>
+                <a16:creationId xmlns:a16="http://schemas.microsoft.com/office/drawing/2014/main" id="{7CD3161B-D889-453B-8A4A-D804A0BC1FE7}"/>
               </a:ext>
             </a:extLst>
           </p:cNvPr>
@@ -2732,7 +2732,7 @@
           <p:cNvPr id="13" name="problem-body-1">
             <a:extLst xmlns:a="http://schemas.openxmlformats.org/drawingml/2006/main">
               <a:ext uri="{FF2B5EF4-FFF2-40B4-BE49-F238E27FC236}">
-                <a16:creationId xmlns:a16="http://schemas.microsoft.com/office/drawing/2014/main" id="{CA2EB6EB-5A9E-4943-91D7-1D9CF7A59C9C}"/>
+                <a16:creationId xmlns:a16="http://schemas.microsoft.com/office/drawing/2014/main" id="{84078649-0444-4F82-A3CB-6EDD6E7D865D}"/>
               </a:ext>
             </a:extLst>
           </p:cNvPr>
@@ -2782,7 +2782,7 @@
           <p:cNvPr id="14" name="problem-card-2">
             <a:extLst xmlns:a="http://schemas.openxmlformats.org/drawingml/2006/main">
               <a:ext uri="{FF2B5EF4-FFF2-40B4-BE49-F238E27FC236}">
-                <a16:creationId xmlns:a16="http://schemas.microsoft.com/office/drawing/2014/main" id="{9C0E33D9-FFEC-41A3-AF4D-C0969D1D2A17}"/>
+                <a16:creationId xmlns:a16="http://schemas.microsoft.com/office/drawing/2014/main" id="{6B438D81-B522-4DAE-AC5B-9F78E5FEA2D8}"/>
               </a:ext>
             </a:extLst>
           </p:cNvPr>
@@ -2817,7 +2817,7 @@
           <p:cNvPr id="15" name="problem-number-2">
             <a:extLst xmlns:a="http://schemas.openxmlformats.org/drawingml/2006/main">
               <a:ext uri="{FF2B5EF4-FFF2-40B4-BE49-F238E27FC236}">
-                <a16:creationId xmlns:a16="http://schemas.microsoft.com/office/drawing/2014/main" id="{14A47894-C15F-4598-AFD2-6CF8FF05E4C2}"/>
+                <a16:creationId xmlns:a16="http://schemas.microsoft.com/office/drawing/2014/main" id="{BBACAB45-BF77-4837-A7EE-7A67936F63F9}"/>
               </a:ext>
             </a:extLst>
           </p:cNvPr>
@@ -2867,7 +2867,7 @@
           <p:cNvPr id="16" name="problem-title-2">
             <a:extLst xmlns:a="http://schemas.openxmlformats.org/drawingml/2006/main">
               <a:ext uri="{FF2B5EF4-FFF2-40B4-BE49-F238E27FC236}">
-                <a16:creationId xmlns:a16="http://schemas.microsoft.com/office/drawing/2014/main" id="{C58EEE39-7F5D-463F-8E49-67DDDA86CA49}"/>
+                <a16:creationId xmlns:a16="http://schemas.microsoft.com/office/drawing/2014/main" id="{92C34566-E660-4ECA-892E-35B87F0050E0}"/>
               </a:ext>
             </a:extLst>
           </p:cNvPr>
@@ -2917,7 +2917,7 @@
           <p:cNvPr id="17" name="problem-body-2">
             <a:extLst xmlns:a="http://schemas.openxmlformats.org/drawingml/2006/main">
               <a:ext uri="{FF2B5EF4-FFF2-40B4-BE49-F238E27FC236}">
-                <a16:creationId xmlns:a16="http://schemas.microsoft.com/office/drawing/2014/main" id="{FED7F536-AB53-47DB-9D5E-850EF63AF4D9}"/>
+                <a16:creationId xmlns:a16="http://schemas.microsoft.com/office/drawing/2014/main" id="{A66A612A-B27A-4195-A61E-2FE7629359BA}"/>
               </a:ext>
             </a:extLst>
           </p:cNvPr>
@@ -2965,7 +2965,7 @@
     </p:spTree>
     <p:extLst>
       <p:ext uri="{BB962C8B-B14F-4D97-AF65-F5344CB8AC3E}">
-        <p14:creationId xmlns:p14="http://schemas.microsoft.com/office/powerpoint/2010/main" val="1617875129"/>
+        <p14:creationId xmlns:p14="http://schemas.microsoft.com/office/powerpoint/2010/main" val="1709972998"/>
       </p:ext>
     </p:extLst>
   </p:cSld>
@@ -2996,7 +2996,7 @@
           <p:cNvPr id="29" name="section-3">
             <a:extLst xmlns:a="http://schemas.openxmlformats.org/drawingml/2006/main">
               <a:ext uri="{FF2B5EF4-FFF2-40B4-BE49-F238E27FC236}">
-                <a16:creationId xmlns:a16="http://schemas.microsoft.com/office/drawing/2014/main" id="{13EE8F65-9563-4031-A533-13ECF9B7528B}"/>
+                <a16:creationId xmlns:a16="http://schemas.microsoft.com/office/drawing/2014/main" id="{A76F7560-18B1-4AD1-98DE-9D8A8467CA2A}"/>
               </a:ext>
             </a:extLst>
           </p:cNvPr>
@@ -3046,7 +3046,7 @@
           <p:cNvPr id="2" name="page-3">
             <a:extLst xmlns:a="http://schemas.openxmlformats.org/drawingml/2006/main">
               <a:ext uri="{FF2B5EF4-FFF2-40B4-BE49-F238E27FC236}">
-                <a16:creationId xmlns:a16="http://schemas.microsoft.com/office/drawing/2014/main" id="{FE9655F9-91C3-4416-91DF-265679B4C4A6}"/>
+                <a16:creationId xmlns:a16="http://schemas.microsoft.com/office/drawing/2014/main" id="{9FA203D6-0BE4-42CB-B636-E79FE38A5C22}"/>
               </a:ext>
             </a:extLst>
           </p:cNvPr>
@@ -3096,7 +3096,7 @@
           <p:cNvPr id="3" name="rule-48-66">
             <a:extLst xmlns:a="http://schemas.openxmlformats.org/drawingml/2006/main">
               <a:ext uri="{FF2B5EF4-FFF2-40B4-BE49-F238E27FC236}">
-                <a16:creationId xmlns:a16="http://schemas.microsoft.com/office/drawing/2014/main" id="{E5D89E68-8452-4B03-899F-35E8FC8E1FDF}"/>
+                <a16:creationId xmlns:a16="http://schemas.microsoft.com/office/drawing/2014/main" id="{69B3CA68-06B9-49B8-9AEF-5E2770E45493}"/>
               </a:ext>
             </a:extLst>
           </p:cNvPr>
@@ -3127,7 +3127,7 @@
           <p:cNvPr id="4" name="title-Upload once. Keep every fact with the right course.">
             <a:extLst xmlns:a="http://schemas.openxmlformats.org/drawingml/2006/main">
               <a:ext uri="{FF2B5EF4-FFF2-40B4-BE49-F238E27FC236}">
-                <a16:creationId xmlns:a16="http://schemas.microsoft.com/office/drawing/2014/main" id="{7EF6AE4E-2321-4086-8FD2-BF400696B9E1}"/>
+                <a16:creationId xmlns:a16="http://schemas.microsoft.com/office/drawing/2014/main" id="{653CA707-07C8-49E1-AA8F-54791A34B88F}"/>
               </a:ext>
             </a:extLst>
           </p:cNvPr>
@@ -3177,7 +3177,7 @@
           <p:cNvPr id="5" name="subtitle-Upload once. Keep every fact with the right course.">
             <a:extLst xmlns:a="http://schemas.openxmlformats.org/drawingml/2006/main">
               <a:ext uri="{FF2B5EF4-FFF2-40B4-BE49-F238E27FC236}">
-                <a16:creationId xmlns:a16="http://schemas.microsoft.com/office/drawing/2014/main" id="{729DAE95-8CAC-4B2F-A78B-58F615115A8B}"/>
+                <a16:creationId xmlns:a16="http://schemas.microsoft.com/office/drawing/2014/main" id="{6A686A7A-E604-43F4-AD39-D57327A25F37}"/>
               </a:ext>
             </a:extLst>
           </p:cNvPr>
@@ -3227,7 +3227,7 @@
           <p:cNvPr id="6" name="step-number-1">
             <a:extLst xmlns:a="http://schemas.openxmlformats.org/drawingml/2006/main">
               <a:ext uri="{FF2B5EF4-FFF2-40B4-BE49-F238E27FC236}">
-                <a16:creationId xmlns:a16="http://schemas.microsoft.com/office/drawing/2014/main" id="{41C2250D-112F-483B-9E00-614A22071B91}"/>
+                <a16:creationId xmlns:a16="http://schemas.microsoft.com/office/drawing/2014/main" id="{A45001DB-FE43-4E12-9A82-5817E80600F5}"/>
               </a:ext>
             </a:extLst>
           </p:cNvPr>
@@ -3260,7 +3260,7 @@
           <p:cNvPr id="7" name="step-digit-1">
             <a:extLst xmlns:a="http://schemas.openxmlformats.org/drawingml/2006/main">
               <a:ext uri="{FF2B5EF4-FFF2-40B4-BE49-F238E27FC236}">
-                <a16:creationId xmlns:a16="http://schemas.microsoft.com/office/drawing/2014/main" id="{AD3FB824-3B55-4B4F-9E37-C233E7BD5916}"/>
+                <a16:creationId xmlns:a16="http://schemas.microsoft.com/office/drawing/2014/main" id="{77F43AAE-3893-4609-9999-4DE3D55AA921}"/>
               </a:ext>
             </a:extLst>
           </p:cNvPr>
@@ -3310,7 +3310,7 @@
           <p:cNvPr id="8" name="step-heading-1">
             <a:extLst xmlns:a="http://schemas.openxmlformats.org/drawingml/2006/main">
               <a:ext uri="{FF2B5EF4-FFF2-40B4-BE49-F238E27FC236}">
-                <a16:creationId xmlns:a16="http://schemas.microsoft.com/office/drawing/2014/main" id="{184693AB-6EB7-4927-B73D-3E7F20238996}"/>
+                <a16:creationId xmlns:a16="http://schemas.microsoft.com/office/drawing/2014/main" id="{649B19FE-5F11-49DE-B719-0EA1BE3841A1}"/>
               </a:ext>
             </a:extLst>
           </p:cNvPr>
@@ -3360,7 +3360,7 @@
           <p:cNvPr id="9" name="step-body-1">
             <a:extLst xmlns:a="http://schemas.openxmlformats.org/drawingml/2006/main">
               <a:ext uri="{FF2B5EF4-FFF2-40B4-BE49-F238E27FC236}">
-                <a16:creationId xmlns:a16="http://schemas.microsoft.com/office/drawing/2014/main" id="{BD878C88-1B33-4C21-830E-F00E00152CF4}"/>
+                <a16:creationId xmlns:a16="http://schemas.microsoft.com/office/drawing/2014/main" id="{C31E3AF5-D2B8-4EC8-A6E3-6EFE0A0167FC}"/>
               </a:ext>
             </a:extLst>
           </p:cNvPr>
@@ -3410,7 +3410,7 @@
           <p:cNvPr id="10" name="rule-116-302">
             <a:extLst xmlns:a="http://schemas.openxmlformats.org/drawingml/2006/main">
               <a:ext uri="{FF2B5EF4-FFF2-40B4-BE49-F238E27FC236}">
-                <a16:creationId xmlns:a16="http://schemas.microsoft.com/office/drawing/2014/main" id="{6671CB29-4EB4-4C86-9EFE-D38432A7D55A}"/>
+                <a16:creationId xmlns:a16="http://schemas.microsoft.com/office/drawing/2014/main" id="{CD76DB5D-56EA-4330-9245-E2F6B66393C6}"/>
               </a:ext>
             </a:extLst>
           </p:cNvPr>
@@ -3441,7 +3441,7 @@
           <p:cNvPr id="11" name="arrow-0">
             <a:extLst xmlns:a="http://schemas.openxmlformats.org/drawingml/2006/main">
               <a:ext uri="{FF2B5EF4-FFF2-40B4-BE49-F238E27FC236}">
-                <a16:creationId xmlns:a16="http://schemas.microsoft.com/office/drawing/2014/main" id="{D16D6F31-0852-4849-B1A4-091CA66BA395}"/>
+                <a16:creationId xmlns:a16="http://schemas.microsoft.com/office/drawing/2014/main" id="{14D1432C-0D1D-4276-8CDB-2A01319AE821}"/>
               </a:ext>
             </a:extLst>
           </p:cNvPr>
@@ -3474,7 +3474,7 @@
           <p:cNvPr id="12" name="step-number-2">
             <a:extLst xmlns:a="http://schemas.openxmlformats.org/drawingml/2006/main">
               <a:ext uri="{FF2B5EF4-FFF2-40B4-BE49-F238E27FC236}">
-                <a16:creationId xmlns:a16="http://schemas.microsoft.com/office/drawing/2014/main" id="{C758AC14-4116-4340-876B-CDA33028538A}"/>
+                <a16:creationId xmlns:a16="http://schemas.microsoft.com/office/drawing/2014/main" id="{20307735-AF98-4406-BB55-D3BDE1D21D35}"/>
               </a:ext>
             </a:extLst>
           </p:cNvPr>
@@ -3507,7 +3507,7 @@
           <p:cNvPr id="13" name="step-digit-2">
             <a:extLst xmlns:a="http://schemas.openxmlformats.org/drawingml/2006/main">
               <a:ext uri="{FF2B5EF4-FFF2-40B4-BE49-F238E27FC236}">
-                <a16:creationId xmlns:a16="http://schemas.microsoft.com/office/drawing/2014/main" id="{C6AB886F-36BF-4977-B387-E6A87129D2A0}"/>
+                <a16:creationId xmlns:a16="http://schemas.microsoft.com/office/drawing/2014/main" id="{FCE9B429-B189-4DF5-96EE-927075A38406}"/>
               </a:ext>
             </a:extLst>
           </p:cNvPr>
@@ -3557,7 +3557,7 @@
           <p:cNvPr id="14" name="step-heading-2">
             <a:extLst xmlns:a="http://schemas.openxmlformats.org/drawingml/2006/main">
               <a:ext uri="{FF2B5EF4-FFF2-40B4-BE49-F238E27FC236}">
-                <a16:creationId xmlns:a16="http://schemas.microsoft.com/office/drawing/2014/main" id="{69A493A6-7E2F-4EDA-B777-9C74D155D7DF}"/>
+                <a16:creationId xmlns:a16="http://schemas.microsoft.com/office/drawing/2014/main" id="{0C3F03F6-D61D-4B66-9D71-1ECC36C207CC}"/>
               </a:ext>
             </a:extLst>
           </p:cNvPr>
@@ -3607,7 +3607,7 @@
           <p:cNvPr id="15" name="step-body-2">
             <a:extLst xmlns:a="http://schemas.openxmlformats.org/drawingml/2006/main">
               <a:ext uri="{FF2B5EF4-FFF2-40B4-BE49-F238E27FC236}">
-                <a16:creationId xmlns:a16="http://schemas.microsoft.com/office/drawing/2014/main" id="{5885FB04-9099-4DC0-BB4B-30043981A17A}"/>
+                <a16:creationId xmlns:a16="http://schemas.microsoft.com/office/drawing/2014/main" id="{F9A08255-83ED-4388-B1A6-1A8C051EED62}"/>
               </a:ext>
             </a:extLst>
           </p:cNvPr>
@@ -3657,7 +3657,7 @@
           <p:cNvPr id="16" name="rule-418-302">
             <a:extLst xmlns:a="http://schemas.openxmlformats.org/drawingml/2006/main">
               <a:ext uri="{FF2B5EF4-FFF2-40B4-BE49-F238E27FC236}">
-                <a16:creationId xmlns:a16="http://schemas.microsoft.com/office/drawing/2014/main" id="{D23FD719-3D8F-4C56-BCA8-C1C4679A1600}"/>
+                <a16:creationId xmlns:a16="http://schemas.microsoft.com/office/drawing/2014/main" id="{6C91E5D1-E7A0-4024-AB6C-5967FAC01F90}"/>
               </a:ext>
             </a:extLst>
           </p:cNvPr>
@@ -3688,7 +3688,7 @@
           <p:cNvPr id="17" name="arrow-1">
             <a:extLst xmlns:a="http://schemas.openxmlformats.org/drawingml/2006/main">
               <a:ext uri="{FF2B5EF4-FFF2-40B4-BE49-F238E27FC236}">
-                <a16:creationId xmlns:a16="http://schemas.microsoft.com/office/drawing/2014/main" id="{3F301BF0-C5EA-49CD-9ADD-B232519FB02E}"/>
+                <a16:creationId xmlns:a16="http://schemas.microsoft.com/office/drawing/2014/main" id="{A1428B0E-548F-4AEB-941D-989F1EC252A1}"/>
               </a:ext>
             </a:extLst>
           </p:cNvPr>
@@ -3721,7 +3721,7 @@
           <p:cNvPr id="18" name="step-number-3">
             <a:extLst xmlns:a="http://schemas.openxmlformats.org/drawingml/2006/main">
               <a:ext uri="{FF2B5EF4-FFF2-40B4-BE49-F238E27FC236}">
-                <a16:creationId xmlns:a16="http://schemas.microsoft.com/office/drawing/2014/main" id="{DE2621B7-5EC3-43AA-92AC-923DCC4A1DF9}"/>
+                <a16:creationId xmlns:a16="http://schemas.microsoft.com/office/drawing/2014/main" id="{C74AF893-8FE2-4440-BB2B-817A7D86C608}"/>
               </a:ext>
             </a:extLst>
           </p:cNvPr>
@@ -3754,7 +3754,7 @@
           <p:cNvPr id="19" name="step-digit-3">
             <a:extLst xmlns:a="http://schemas.openxmlformats.org/drawingml/2006/main">
               <a:ext uri="{FF2B5EF4-FFF2-40B4-BE49-F238E27FC236}">
-                <a16:creationId xmlns:a16="http://schemas.microsoft.com/office/drawing/2014/main" id="{14E73AE7-C4E4-443D-BE2B-B5EA15BEEFE8}"/>
+                <a16:creationId xmlns:a16="http://schemas.microsoft.com/office/drawing/2014/main" id="{3F836F8B-8A0D-4C92-A52E-F750A51164E1}"/>
               </a:ext>
             </a:extLst>
           </p:cNvPr>
@@ -3804,7 +3804,7 @@
           <p:cNvPr id="20" name="step-heading-3">
             <a:extLst xmlns:a="http://schemas.openxmlformats.org/drawingml/2006/main">
               <a:ext uri="{FF2B5EF4-FFF2-40B4-BE49-F238E27FC236}">
-                <a16:creationId xmlns:a16="http://schemas.microsoft.com/office/drawing/2014/main" id="{DC2AF1D0-0C11-4320-AAE8-889E58E3D4FE}"/>
+                <a16:creationId xmlns:a16="http://schemas.microsoft.com/office/drawing/2014/main" id="{086C9D35-5142-4071-B85C-88E76DC28D43}"/>
               </a:ext>
             </a:extLst>
           </p:cNvPr>
@@ -3854,7 +3854,7 @@
           <p:cNvPr id="21" name="step-body-3">
             <a:extLst xmlns:a="http://schemas.openxmlformats.org/drawingml/2006/main">
               <a:ext uri="{FF2B5EF4-FFF2-40B4-BE49-F238E27FC236}">
-                <a16:creationId xmlns:a16="http://schemas.microsoft.com/office/drawing/2014/main" id="{DC411792-184D-4589-8ABC-583F6D801620}"/>
+                <a16:creationId xmlns:a16="http://schemas.microsoft.com/office/drawing/2014/main" id="{FF8976A6-A655-4226-8BE0-CB94454C4D77}"/>
               </a:ext>
             </a:extLst>
           </p:cNvPr>
@@ -3904,7 +3904,7 @@
           <p:cNvPr id="22" name="rule-720-302">
             <a:extLst xmlns:a="http://schemas.openxmlformats.org/drawingml/2006/main">
               <a:ext uri="{FF2B5EF4-FFF2-40B4-BE49-F238E27FC236}">
-                <a16:creationId xmlns:a16="http://schemas.microsoft.com/office/drawing/2014/main" id="{FAF3D9C3-439A-4917-A50B-28B0043B3CAC}"/>
+                <a16:creationId xmlns:a16="http://schemas.microsoft.com/office/drawing/2014/main" id="{434889F9-FDFC-4824-AA87-FE64645F060A}"/>
               </a:ext>
             </a:extLst>
           </p:cNvPr>
@@ -3935,7 +3935,7 @@
           <p:cNvPr id="23" name="arrow-2">
             <a:extLst xmlns:a="http://schemas.openxmlformats.org/drawingml/2006/main">
               <a:ext uri="{FF2B5EF4-FFF2-40B4-BE49-F238E27FC236}">
-                <a16:creationId xmlns:a16="http://schemas.microsoft.com/office/drawing/2014/main" id="{8B7CFC15-D031-4AFD-A22E-4C65E73C6606}"/>
+                <a16:creationId xmlns:a16="http://schemas.microsoft.com/office/drawing/2014/main" id="{6BC8FF49-4487-4B4C-BB3B-88B075F66495}"/>
               </a:ext>
             </a:extLst>
           </p:cNvPr>
@@ -3968,7 +3968,7 @@
           <p:cNvPr id="24" name="step-number-4">
             <a:extLst xmlns:a="http://schemas.openxmlformats.org/drawingml/2006/main">
               <a:ext uri="{FF2B5EF4-FFF2-40B4-BE49-F238E27FC236}">
-                <a16:creationId xmlns:a16="http://schemas.microsoft.com/office/drawing/2014/main" id="{0519DA33-C9C4-4FC1-85D6-05BA2FD40F66}"/>
+                <a16:creationId xmlns:a16="http://schemas.microsoft.com/office/drawing/2014/main" id="{C38BF6D6-1A86-4558-8C3C-D6F280B8B1A4}"/>
               </a:ext>
             </a:extLst>
           </p:cNvPr>
@@ -4001,7 +4001,7 @@
           <p:cNvPr id="25" name="step-digit-4">
             <a:extLst xmlns:a="http://schemas.openxmlformats.org/drawingml/2006/main">
               <a:ext uri="{FF2B5EF4-FFF2-40B4-BE49-F238E27FC236}">
-                <a16:creationId xmlns:a16="http://schemas.microsoft.com/office/drawing/2014/main" id="{AAEE159C-153A-4CD6-8F86-154E938CB6F6}"/>
+                <a16:creationId xmlns:a16="http://schemas.microsoft.com/office/drawing/2014/main" id="{4BF137AB-921C-4D4A-9443-CECC3C7EDE34}"/>
               </a:ext>
             </a:extLst>
           </p:cNvPr>
@@ -4051,7 +4051,7 @@
           <p:cNvPr id="26" name="step-heading-4">
             <a:extLst xmlns:a="http://schemas.openxmlformats.org/drawingml/2006/main">
               <a:ext uri="{FF2B5EF4-FFF2-40B4-BE49-F238E27FC236}">
-                <a16:creationId xmlns:a16="http://schemas.microsoft.com/office/drawing/2014/main" id="{7AE5F467-1041-4647-9DBF-516E92AFD60F}"/>
+                <a16:creationId xmlns:a16="http://schemas.microsoft.com/office/drawing/2014/main" id="{B90FCCC2-6D43-4334-804A-1538B68EE8A8}"/>
               </a:ext>
             </a:extLst>
           </p:cNvPr>
@@ -4101,7 +4101,7 @@
           <p:cNvPr id="27" name="step-body-4">
             <a:extLst xmlns:a="http://schemas.openxmlformats.org/drawingml/2006/main">
               <a:ext uri="{FF2B5EF4-FFF2-40B4-BE49-F238E27FC236}">
-                <a16:creationId xmlns:a16="http://schemas.microsoft.com/office/drawing/2014/main" id="{1D79D506-0EEE-45B5-B881-FB586B056A21}"/>
+                <a16:creationId xmlns:a16="http://schemas.microsoft.com/office/drawing/2014/main" id="{21578FDE-202A-4A4D-A080-8C031703B2A9}"/>
               </a:ext>
             </a:extLst>
           </p:cNvPr>
@@ -4151,7 +4151,7 @@
           <p:cNvPr id="28" name="workflow-result">
             <a:extLst xmlns:a="http://schemas.openxmlformats.org/drawingml/2006/main">
               <a:ext uri="{FF2B5EF4-FFF2-40B4-BE49-F238E27FC236}">
-                <a16:creationId xmlns:a16="http://schemas.microsoft.com/office/drawing/2014/main" id="{4E72650F-F30F-40C5-A019-47873A7508A6}"/>
+                <a16:creationId xmlns:a16="http://schemas.microsoft.com/office/drawing/2014/main" id="{05FF0A2C-F990-45D6-B76E-CB57A580EBFD}"/>
               </a:ext>
             </a:extLst>
           </p:cNvPr>
@@ -4199,7 +4199,7 @@
     </p:spTree>
     <p:extLst>
       <p:ext uri="{BB962C8B-B14F-4D97-AF65-F5344CB8AC3E}">
-        <p14:creationId xmlns:p14="http://schemas.microsoft.com/office/powerpoint/2010/main" val="1723410769"/>
+        <p14:creationId xmlns:p14="http://schemas.microsoft.com/office/powerpoint/2010/main" val="799625306"/>
       </p:ext>
     </p:extLst>
   </p:cSld>
@@ -4230,7 +4230,7 @@
           <p:cNvPr id="42" name="section-4">
             <a:extLst xmlns:a="http://schemas.openxmlformats.org/drawingml/2006/main">
               <a:ext uri="{FF2B5EF4-FFF2-40B4-BE49-F238E27FC236}">
-                <a16:creationId xmlns:a16="http://schemas.microsoft.com/office/drawing/2014/main" id="{44B8CE2C-31A5-4773-8981-59ADB80CEEFC}"/>
+                <a16:creationId xmlns:a16="http://schemas.microsoft.com/office/drawing/2014/main" id="{6AFAF402-3AF7-4506-8F00-9C62D858F9D6}"/>
               </a:ext>
             </a:extLst>
           </p:cNvPr>
@@ -4280,7 +4280,7 @@
           <p:cNvPr id="2" name="page-4">
             <a:extLst xmlns:a="http://schemas.openxmlformats.org/drawingml/2006/main">
               <a:ext uri="{FF2B5EF4-FFF2-40B4-BE49-F238E27FC236}">
-                <a16:creationId xmlns:a16="http://schemas.microsoft.com/office/drawing/2014/main" id="{92AE81CA-5FB4-4FD6-811C-429E675B9882}"/>
+                <a16:creationId xmlns:a16="http://schemas.microsoft.com/office/drawing/2014/main" id="{E47B4816-B886-44AD-A852-A2DAA286A272}"/>
               </a:ext>
             </a:extLst>
           </p:cNvPr>
@@ -4330,7 +4330,7 @@
           <p:cNvPr id="3" name="rule-48-66">
             <a:extLst xmlns:a="http://schemas.openxmlformats.org/drawingml/2006/main">
               <a:ext uri="{FF2B5EF4-FFF2-40B4-BE49-F238E27FC236}">
-                <a16:creationId xmlns:a16="http://schemas.microsoft.com/office/drawing/2014/main" id="{BC574603-CD4F-4878-9F06-436D548D1526}"/>
+                <a16:creationId xmlns:a16="http://schemas.microsoft.com/office/drawing/2014/main" id="{D9AF9379-0AB7-40FC-BFAF-325176256E46}"/>
               </a:ext>
             </a:extLst>
           </p:cNvPr>
@@ -4361,7 +4361,7 @@
           <p:cNvPr id="4" name="title-ClassPilot closes the loop from prompt to submission.">
             <a:extLst xmlns:a="http://schemas.openxmlformats.org/drawingml/2006/main">
               <a:ext uri="{FF2B5EF4-FFF2-40B4-BE49-F238E27FC236}">
-                <a16:creationId xmlns:a16="http://schemas.microsoft.com/office/drawing/2014/main" id="{63DCCB33-9F37-4BDD-92A5-AB6526022D0D}"/>
+                <a16:creationId xmlns:a16="http://schemas.microsoft.com/office/drawing/2014/main" id="{7EB0AAA5-2C3E-423E-922F-985C13B0EBE0}"/>
               </a:ext>
             </a:extLst>
           </p:cNvPr>
@@ -4411,7 +4411,7 @@
           <p:cNvPr id="5" name="subtitle-ClassPilot closes the loop from prompt to submission.">
             <a:extLst xmlns:a="http://schemas.openxmlformats.org/drawingml/2006/main">
               <a:ext uri="{FF2B5EF4-FFF2-40B4-BE49-F238E27FC236}">
-                <a16:creationId xmlns:a16="http://schemas.microsoft.com/office/drawing/2014/main" id="{70166D9B-9AED-49F6-BED2-DCF36EFE96DE}"/>
+                <a16:creationId xmlns:a16="http://schemas.microsoft.com/office/drawing/2014/main" id="{F1AE8BE5-4D6D-4775-A100-0793E8CA9F9C}"/>
               </a:ext>
             </a:extLst>
           </p:cNvPr>
@@ -4461,7 +4461,7 @@
           <p:cNvPr id="6" name="loop-node-0">
             <a:extLst xmlns:a="http://schemas.openxmlformats.org/drawingml/2006/main">
               <a:ext uri="{FF2B5EF4-FFF2-40B4-BE49-F238E27FC236}">
-                <a16:creationId xmlns:a16="http://schemas.microsoft.com/office/drawing/2014/main" id="{438807E0-950F-420B-B613-385554BB8A0E}"/>
+                <a16:creationId xmlns:a16="http://schemas.microsoft.com/office/drawing/2014/main" id="{3A21CBE7-04C2-40C6-A1D8-08932C9E1004}"/>
               </a:ext>
             </a:extLst>
           </p:cNvPr>
@@ -4494,7 +4494,7 @@
           <p:cNvPr id="7" name="loop-number-0">
             <a:extLst xmlns:a="http://schemas.openxmlformats.org/drawingml/2006/main">
               <a:ext uri="{FF2B5EF4-FFF2-40B4-BE49-F238E27FC236}">
-                <a16:creationId xmlns:a16="http://schemas.microsoft.com/office/drawing/2014/main" id="{E37299C4-FC37-4AD1-AC47-64A6E281D1FD}"/>
+                <a16:creationId xmlns:a16="http://schemas.microsoft.com/office/drawing/2014/main" id="{A9BCD19A-9529-4EA8-8DBE-EF5C6B3CBCD2}"/>
               </a:ext>
             </a:extLst>
           </p:cNvPr>
@@ -4544,7 +4544,7 @@
           <p:cNvPr id="8" name="loop-title-0">
             <a:extLst xmlns:a="http://schemas.openxmlformats.org/drawingml/2006/main">
               <a:ext uri="{FF2B5EF4-FFF2-40B4-BE49-F238E27FC236}">
-                <a16:creationId xmlns:a16="http://schemas.microsoft.com/office/drawing/2014/main" id="{29592C90-1112-4E57-8870-C1B5BA3B3612}"/>
+                <a16:creationId xmlns:a16="http://schemas.microsoft.com/office/drawing/2014/main" id="{CBC5FE59-7013-4773-B02E-C26CF95E2065}"/>
               </a:ext>
             </a:extLst>
           </p:cNvPr>
@@ -4594,7 +4594,7 @@
           <p:cNvPr id="9" name="loop-body-0">
             <a:extLst xmlns:a="http://schemas.openxmlformats.org/drawingml/2006/main">
               <a:ext uri="{FF2B5EF4-FFF2-40B4-BE49-F238E27FC236}">
-                <a16:creationId xmlns:a16="http://schemas.microsoft.com/office/drawing/2014/main" id="{9216B843-1EA8-4EEF-B2EE-55A575FC30FC}"/>
+                <a16:creationId xmlns:a16="http://schemas.microsoft.com/office/drawing/2014/main" id="{9E4E3E7F-C84F-4EFA-9B9E-73860DE25F14}"/>
               </a:ext>
             </a:extLst>
           </p:cNvPr>
@@ -4644,7 +4644,7 @@
           <p:cNvPr id="10" name="rule-102-298">
             <a:extLst xmlns:a="http://schemas.openxmlformats.org/drawingml/2006/main">
               <a:ext uri="{FF2B5EF4-FFF2-40B4-BE49-F238E27FC236}">
-                <a16:creationId xmlns:a16="http://schemas.microsoft.com/office/drawing/2014/main" id="{4D054A14-B07B-42EF-9380-9AC64416CFE7}"/>
+                <a16:creationId xmlns:a16="http://schemas.microsoft.com/office/drawing/2014/main" id="{88CD023E-9A2A-4CB2-9BFD-8D45AB474AEE}"/>
               </a:ext>
             </a:extLst>
           </p:cNvPr>
@@ -4675,7 +4675,7 @@
           <p:cNvPr id="11" name="loop-arrow-0">
             <a:extLst xmlns:a="http://schemas.openxmlformats.org/drawingml/2006/main">
               <a:ext uri="{FF2B5EF4-FFF2-40B4-BE49-F238E27FC236}">
-                <a16:creationId xmlns:a16="http://schemas.microsoft.com/office/drawing/2014/main" id="{80851DCD-B753-40EA-AD36-B00D74B0D565}"/>
+                <a16:creationId xmlns:a16="http://schemas.microsoft.com/office/drawing/2014/main" id="{549ACD5E-4D01-49FB-B4D0-7AAE9D67F09B}"/>
               </a:ext>
             </a:extLst>
           </p:cNvPr>
@@ -4708,7 +4708,7 @@
           <p:cNvPr id="12" name="loop-node-1">
             <a:extLst xmlns:a="http://schemas.openxmlformats.org/drawingml/2006/main">
               <a:ext uri="{FF2B5EF4-FFF2-40B4-BE49-F238E27FC236}">
-                <a16:creationId xmlns:a16="http://schemas.microsoft.com/office/drawing/2014/main" id="{870032A0-EBBD-4574-88AA-BEBA55FAC691}"/>
+                <a16:creationId xmlns:a16="http://schemas.microsoft.com/office/drawing/2014/main" id="{F9B38F63-696D-4D61-89F2-E2A18CC4B13A}"/>
               </a:ext>
             </a:extLst>
           </p:cNvPr>
@@ -4741,7 +4741,7 @@
           <p:cNvPr id="13" name="loop-number-1">
             <a:extLst xmlns:a="http://schemas.openxmlformats.org/drawingml/2006/main">
               <a:ext uri="{FF2B5EF4-FFF2-40B4-BE49-F238E27FC236}">
-                <a16:creationId xmlns:a16="http://schemas.microsoft.com/office/drawing/2014/main" id="{230D45B3-0E0E-431B-A2FF-80D0D7A2554A}"/>
+                <a16:creationId xmlns:a16="http://schemas.microsoft.com/office/drawing/2014/main" id="{CCF244A5-BD1F-400F-B4C7-00B0326BBC38}"/>
               </a:ext>
             </a:extLst>
           </p:cNvPr>
@@ -4791,7 +4791,7 @@
           <p:cNvPr id="14" name="loop-title-1">
             <a:extLst xmlns:a="http://schemas.openxmlformats.org/drawingml/2006/main">
               <a:ext uri="{FF2B5EF4-FFF2-40B4-BE49-F238E27FC236}">
-                <a16:creationId xmlns:a16="http://schemas.microsoft.com/office/drawing/2014/main" id="{944A51C6-1FAE-473B-BB1C-1230B7693DE0}"/>
+                <a16:creationId xmlns:a16="http://schemas.microsoft.com/office/drawing/2014/main" id="{94DDAD09-0AB4-4B4F-B7E5-7766FD83D8F0}"/>
               </a:ext>
             </a:extLst>
           </p:cNvPr>
@@ -4841,7 +4841,7 @@
           <p:cNvPr id="15" name="loop-body-1">
             <a:extLst xmlns:a="http://schemas.openxmlformats.org/drawingml/2006/main">
               <a:ext uri="{FF2B5EF4-FFF2-40B4-BE49-F238E27FC236}">
-                <a16:creationId xmlns:a16="http://schemas.microsoft.com/office/drawing/2014/main" id="{75D3B1F8-AE77-4CA2-ABAA-8BAD8482A474}"/>
+                <a16:creationId xmlns:a16="http://schemas.microsoft.com/office/drawing/2014/main" id="{76B5FA40-70E2-4D58-8CEB-BE26041E0D08}"/>
               </a:ext>
             </a:extLst>
           </p:cNvPr>
@@ -4891,7 +4891,7 @@
           <p:cNvPr id="16" name="rule-300-298">
             <a:extLst xmlns:a="http://schemas.openxmlformats.org/drawingml/2006/main">
               <a:ext uri="{FF2B5EF4-FFF2-40B4-BE49-F238E27FC236}">
-                <a16:creationId xmlns:a16="http://schemas.microsoft.com/office/drawing/2014/main" id="{F00F7828-EBC2-443D-85BF-F85F4FFEA11B}"/>
+                <a16:creationId xmlns:a16="http://schemas.microsoft.com/office/drawing/2014/main" id="{E9BAEA6C-C249-40E4-8FD8-E6AA019064B7}"/>
               </a:ext>
             </a:extLst>
           </p:cNvPr>
@@ -4922,7 +4922,7 @@
           <p:cNvPr id="17" name="loop-arrow-1">
             <a:extLst xmlns:a="http://schemas.openxmlformats.org/drawingml/2006/main">
               <a:ext uri="{FF2B5EF4-FFF2-40B4-BE49-F238E27FC236}">
-                <a16:creationId xmlns:a16="http://schemas.microsoft.com/office/drawing/2014/main" id="{E79B337C-F218-4791-8532-677C5856D689}"/>
+                <a16:creationId xmlns:a16="http://schemas.microsoft.com/office/drawing/2014/main" id="{9048AFD8-3D4A-4658-A57B-EA1AFBE07AB7}"/>
               </a:ext>
             </a:extLst>
           </p:cNvPr>
@@ -4955,7 +4955,7 @@
           <p:cNvPr id="18" name="loop-node-2">
             <a:extLst xmlns:a="http://schemas.openxmlformats.org/drawingml/2006/main">
               <a:ext uri="{FF2B5EF4-FFF2-40B4-BE49-F238E27FC236}">
-                <a16:creationId xmlns:a16="http://schemas.microsoft.com/office/drawing/2014/main" id="{1BF53103-1534-46BE-96B6-326756C2B604}"/>
+                <a16:creationId xmlns:a16="http://schemas.microsoft.com/office/drawing/2014/main" id="{E0E7D696-26FB-4F2B-9152-11CAA3319C31}"/>
               </a:ext>
             </a:extLst>
           </p:cNvPr>
@@ -4988,7 +4988,7 @@
           <p:cNvPr id="19" name="loop-number-2">
             <a:extLst xmlns:a="http://schemas.openxmlformats.org/drawingml/2006/main">
               <a:ext uri="{FF2B5EF4-FFF2-40B4-BE49-F238E27FC236}">
-                <a16:creationId xmlns:a16="http://schemas.microsoft.com/office/drawing/2014/main" id="{297A2C56-C6A8-4653-B9DB-972AF8CA928E}"/>
+                <a16:creationId xmlns:a16="http://schemas.microsoft.com/office/drawing/2014/main" id="{5E725DC9-DD14-4F1C-B9A3-3EC169B4C036}"/>
               </a:ext>
             </a:extLst>
           </p:cNvPr>
@@ -5038,7 +5038,7 @@
           <p:cNvPr id="20" name="loop-title-2">
             <a:extLst xmlns:a="http://schemas.openxmlformats.org/drawingml/2006/main">
               <a:ext uri="{FF2B5EF4-FFF2-40B4-BE49-F238E27FC236}">
-                <a16:creationId xmlns:a16="http://schemas.microsoft.com/office/drawing/2014/main" id="{54F26BED-6368-4A91-96C8-9746F3C6EE59}"/>
+                <a16:creationId xmlns:a16="http://schemas.microsoft.com/office/drawing/2014/main" id="{B4DF27B9-C433-4C18-8833-C0BE6FCED271}"/>
               </a:ext>
             </a:extLst>
           </p:cNvPr>
@@ -5088,7 +5088,7 @@
           <p:cNvPr id="21" name="loop-body-2">
             <a:extLst xmlns:a="http://schemas.openxmlformats.org/drawingml/2006/main">
               <a:ext uri="{FF2B5EF4-FFF2-40B4-BE49-F238E27FC236}">
-                <a16:creationId xmlns:a16="http://schemas.microsoft.com/office/drawing/2014/main" id="{057D5EA6-10C5-49BF-B2E7-D98C27020C3C}"/>
+                <a16:creationId xmlns:a16="http://schemas.microsoft.com/office/drawing/2014/main" id="{7E495C71-E70F-410F-9BF4-DD3595D54046}"/>
               </a:ext>
             </a:extLst>
           </p:cNvPr>
@@ -5138,7 +5138,7 @@
           <p:cNvPr id="22" name="rule-498-298">
             <a:extLst xmlns:a="http://schemas.openxmlformats.org/drawingml/2006/main">
               <a:ext uri="{FF2B5EF4-FFF2-40B4-BE49-F238E27FC236}">
-                <a16:creationId xmlns:a16="http://schemas.microsoft.com/office/drawing/2014/main" id="{A5AAE025-A7E7-40E7-BE3C-C874CA8635F3}"/>
+                <a16:creationId xmlns:a16="http://schemas.microsoft.com/office/drawing/2014/main" id="{132C7B25-93D7-4682-82CF-AE0E4C214DA1}"/>
               </a:ext>
             </a:extLst>
           </p:cNvPr>
@@ -5169,7 +5169,7 @@
           <p:cNvPr id="23" name="loop-arrow-2">
             <a:extLst xmlns:a="http://schemas.openxmlformats.org/drawingml/2006/main">
               <a:ext uri="{FF2B5EF4-FFF2-40B4-BE49-F238E27FC236}">
-                <a16:creationId xmlns:a16="http://schemas.microsoft.com/office/drawing/2014/main" id="{0CE733CC-5F27-4463-97AC-FBAFD0042D04}"/>
+                <a16:creationId xmlns:a16="http://schemas.microsoft.com/office/drawing/2014/main" id="{E9DAE346-D3A7-4A2C-BA93-94EFCBBEB728}"/>
               </a:ext>
             </a:extLst>
           </p:cNvPr>
@@ -5202,7 +5202,7 @@
           <p:cNvPr id="24" name="loop-node-3">
             <a:extLst xmlns:a="http://schemas.openxmlformats.org/drawingml/2006/main">
               <a:ext uri="{FF2B5EF4-FFF2-40B4-BE49-F238E27FC236}">
-                <a16:creationId xmlns:a16="http://schemas.microsoft.com/office/drawing/2014/main" id="{2D0C4F7F-0DC3-42DD-A785-3C750CF0D418}"/>
+                <a16:creationId xmlns:a16="http://schemas.microsoft.com/office/drawing/2014/main" id="{F33314E0-3792-4257-A991-F7698D14B7F4}"/>
               </a:ext>
             </a:extLst>
           </p:cNvPr>
@@ -5235,7 +5235,7 @@
           <p:cNvPr id="25" name="loop-number-3">
             <a:extLst xmlns:a="http://schemas.openxmlformats.org/drawingml/2006/main">
               <a:ext uri="{FF2B5EF4-FFF2-40B4-BE49-F238E27FC236}">
-                <a16:creationId xmlns:a16="http://schemas.microsoft.com/office/drawing/2014/main" id="{3404F5B8-7F0F-480D-82E0-B9B8277ACBCC}"/>
+                <a16:creationId xmlns:a16="http://schemas.microsoft.com/office/drawing/2014/main" id="{266CD194-9858-458E-9745-3A7569DC07E4}"/>
               </a:ext>
             </a:extLst>
           </p:cNvPr>
@@ -5285,7 +5285,7 @@
           <p:cNvPr id="26" name="loop-title-3">
             <a:extLst xmlns:a="http://schemas.openxmlformats.org/drawingml/2006/main">
               <a:ext uri="{FF2B5EF4-FFF2-40B4-BE49-F238E27FC236}">
-                <a16:creationId xmlns:a16="http://schemas.microsoft.com/office/drawing/2014/main" id="{DA9BD617-B6ED-49F9-B38B-FA4830826730}"/>
+                <a16:creationId xmlns:a16="http://schemas.microsoft.com/office/drawing/2014/main" id="{6F9734C2-8E9E-4FCF-BF30-794FE5A95A23}"/>
               </a:ext>
             </a:extLst>
           </p:cNvPr>
@@ -5335,7 +5335,7 @@
           <p:cNvPr id="27" name="loop-body-3">
             <a:extLst xmlns:a="http://schemas.openxmlformats.org/drawingml/2006/main">
               <a:ext uri="{FF2B5EF4-FFF2-40B4-BE49-F238E27FC236}">
-                <a16:creationId xmlns:a16="http://schemas.microsoft.com/office/drawing/2014/main" id="{9595BCEA-C917-4935-BB19-2D63BA837EF7}"/>
+                <a16:creationId xmlns:a16="http://schemas.microsoft.com/office/drawing/2014/main" id="{C4E97178-38DA-475E-8C9A-60FE39A195C6}"/>
               </a:ext>
             </a:extLst>
           </p:cNvPr>
@@ -5385,7 +5385,7 @@
           <p:cNvPr id="28" name="rule-696-298">
             <a:extLst xmlns:a="http://schemas.openxmlformats.org/drawingml/2006/main">
               <a:ext uri="{FF2B5EF4-FFF2-40B4-BE49-F238E27FC236}">
-                <a16:creationId xmlns:a16="http://schemas.microsoft.com/office/drawing/2014/main" id="{9868B865-36F1-4228-AC66-9F3DCCC5DAED}"/>
+                <a16:creationId xmlns:a16="http://schemas.microsoft.com/office/drawing/2014/main" id="{290ACDB7-65AF-410F-9CBC-051959FA6E7E}"/>
               </a:ext>
             </a:extLst>
           </p:cNvPr>
@@ -5416,7 +5416,7 @@
           <p:cNvPr id="29" name="loop-arrow-3">
             <a:extLst xmlns:a="http://schemas.openxmlformats.org/drawingml/2006/main">
               <a:ext uri="{FF2B5EF4-FFF2-40B4-BE49-F238E27FC236}">
-                <a16:creationId xmlns:a16="http://schemas.microsoft.com/office/drawing/2014/main" id="{2DC85590-43F2-4A8D-8F08-7ABB59150CD7}"/>
+                <a16:creationId xmlns:a16="http://schemas.microsoft.com/office/drawing/2014/main" id="{EFF8C2E9-CF0A-4159-A62B-B480B56C3872}"/>
               </a:ext>
             </a:extLst>
           </p:cNvPr>
@@ -5449,7 +5449,7 @@
           <p:cNvPr id="30" name="loop-node-4">
             <a:extLst xmlns:a="http://schemas.openxmlformats.org/drawingml/2006/main">
               <a:ext uri="{FF2B5EF4-FFF2-40B4-BE49-F238E27FC236}">
-                <a16:creationId xmlns:a16="http://schemas.microsoft.com/office/drawing/2014/main" id="{92B9E6EC-6654-420A-8245-F706AF743333}"/>
+                <a16:creationId xmlns:a16="http://schemas.microsoft.com/office/drawing/2014/main" id="{4B752079-49B4-49ED-94A9-D95F2763E02A}"/>
               </a:ext>
             </a:extLst>
           </p:cNvPr>
@@ -5482,7 +5482,7 @@
           <p:cNvPr id="31" name="loop-number-4">
             <a:extLst xmlns:a="http://schemas.openxmlformats.org/drawingml/2006/main">
               <a:ext uri="{FF2B5EF4-FFF2-40B4-BE49-F238E27FC236}">
-                <a16:creationId xmlns:a16="http://schemas.microsoft.com/office/drawing/2014/main" id="{CA87C956-9EE0-4FD0-940A-E1FA0C9048EE}"/>
+                <a16:creationId xmlns:a16="http://schemas.microsoft.com/office/drawing/2014/main" id="{7D22B758-0608-4E00-9943-CF24D5BDC685}"/>
               </a:ext>
             </a:extLst>
           </p:cNvPr>
@@ -5532,7 +5532,7 @@
           <p:cNvPr id="32" name="loop-title-4">
             <a:extLst xmlns:a="http://schemas.openxmlformats.org/drawingml/2006/main">
               <a:ext uri="{FF2B5EF4-FFF2-40B4-BE49-F238E27FC236}">
-                <a16:creationId xmlns:a16="http://schemas.microsoft.com/office/drawing/2014/main" id="{CF7005D1-7A3B-47D5-8622-BD335C33A90F}"/>
+                <a16:creationId xmlns:a16="http://schemas.microsoft.com/office/drawing/2014/main" id="{540394E3-9FBC-42F1-9688-3D0013038098}"/>
               </a:ext>
             </a:extLst>
           </p:cNvPr>
@@ -5582,7 +5582,7 @@
           <p:cNvPr id="33" name="loop-body-4">
             <a:extLst xmlns:a="http://schemas.openxmlformats.org/drawingml/2006/main">
               <a:ext uri="{FF2B5EF4-FFF2-40B4-BE49-F238E27FC236}">
-                <a16:creationId xmlns:a16="http://schemas.microsoft.com/office/drawing/2014/main" id="{34EA7839-A276-42E3-B208-6711543A6BF5}"/>
+                <a16:creationId xmlns:a16="http://schemas.microsoft.com/office/drawing/2014/main" id="{092EA5D1-CAAD-4A28-AF7B-8F6765ED9EAE}"/>
               </a:ext>
             </a:extLst>
           </p:cNvPr>
@@ -5632,7 +5632,7 @@
           <p:cNvPr id="34" name="rule-894-298">
             <a:extLst xmlns:a="http://schemas.openxmlformats.org/drawingml/2006/main">
               <a:ext uri="{FF2B5EF4-FFF2-40B4-BE49-F238E27FC236}">
-                <a16:creationId xmlns:a16="http://schemas.microsoft.com/office/drawing/2014/main" id="{EA4BB8B1-0A58-4140-B61D-6C2F002C2DB5}"/>
+                <a16:creationId xmlns:a16="http://schemas.microsoft.com/office/drawing/2014/main" id="{97F668DC-48D9-4763-B8BD-447E026D2AEE}"/>
               </a:ext>
             </a:extLst>
           </p:cNvPr>
@@ -5663,7 +5663,7 @@
           <p:cNvPr id="35" name="loop-arrow-4">
             <a:extLst xmlns:a="http://schemas.openxmlformats.org/drawingml/2006/main">
               <a:ext uri="{FF2B5EF4-FFF2-40B4-BE49-F238E27FC236}">
-                <a16:creationId xmlns:a16="http://schemas.microsoft.com/office/drawing/2014/main" id="{E814C3FC-1F20-457E-89D6-29C9379A6264}"/>
+                <a16:creationId xmlns:a16="http://schemas.microsoft.com/office/drawing/2014/main" id="{E64F245C-34F5-447A-84A8-074C67F06B29}"/>
               </a:ext>
             </a:extLst>
           </p:cNvPr>
@@ -5696,7 +5696,7 @@
           <p:cNvPr id="36" name="loop-node-5">
             <a:extLst xmlns:a="http://schemas.openxmlformats.org/drawingml/2006/main">
               <a:ext uri="{FF2B5EF4-FFF2-40B4-BE49-F238E27FC236}">
-                <a16:creationId xmlns:a16="http://schemas.microsoft.com/office/drawing/2014/main" id="{4473E7D6-EA70-4AB8-8E76-088709FFDC0D}"/>
+                <a16:creationId xmlns:a16="http://schemas.microsoft.com/office/drawing/2014/main" id="{88B0AC93-C2B5-4728-A90D-DF0E1EB67239}"/>
               </a:ext>
             </a:extLst>
           </p:cNvPr>
@@ -5729,7 +5729,7 @@
           <p:cNvPr id="37" name="loop-number-5">
             <a:extLst xmlns:a="http://schemas.openxmlformats.org/drawingml/2006/main">
               <a:ext uri="{FF2B5EF4-FFF2-40B4-BE49-F238E27FC236}">
-                <a16:creationId xmlns:a16="http://schemas.microsoft.com/office/drawing/2014/main" id="{D4B470F4-E577-4EE5-B12A-13D91FF2F5C2}"/>
+                <a16:creationId xmlns:a16="http://schemas.microsoft.com/office/drawing/2014/main" id="{D4495106-C223-497A-82E8-54891319689B}"/>
               </a:ext>
             </a:extLst>
           </p:cNvPr>
@@ -5779,7 +5779,7 @@
           <p:cNvPr id="38" name="loop-title-5">
             <a:extLst xmlns:a="http://schemas.openxmlformats.org/drawingml/2006/main">
               <a:ext uri="{FF2B5EF4-FFF2-40B4-BE49-F238E27FC236}">
-                <a16:creationId xmlns:a16="http://schemas.microsoft.com/office/drawing/2014/main" id="{B96D63F0-D949-41C3-B6E4-D010B425FA60}"/>
+                <a16:creationId xmlns:a16="http://schemas.microsoft.com/office/drawing/2014/main" id="{676055F1-6D9D-4DDB-84FE-F06D1440D58E}"/>
               </a:ext>
             </a:extLst>
           </p:cNvPr>
@@ -5829,7 +5829,7 @@
           <p:cNvPr id="39" name="loop-body-5">
             <a:extLst xmlns:a="http://schemas.openxmlformats.org/drawingml/2006/main">
               <a:ext uri="{FF2B5EF4-FFF2-40B4-BE49-F238E27FC236}">
-                <a16:creationId xmlns:a16="http://schemas.microsoft.com/office/drawing/2014/main" id="{1718CBF2-3B5C-46A9-B0C7-8663C7032158}"/>
+                <a16:creationId xmlns:a16="http://schemas.microsoft.com/office/drawing/2014/main" id="{DD97A5F1-B52D-4603-963F-36344559CC63}"/>
               </a:ext>
             </a:extLst>
           </p:cNvPr>
@@ -5879,7 +5879,7 @@
           <p:cNvPr id="40" name="loop-result-band">
             <a:extLst xmlns:a="http://schemas.openxmlformats.org/drawingml/2006/main">
               <a:ext uri="{FF2B5EF4-FFF2-40B4-BE49-F238E27FC236}">
-                <a16:creationId xmlns:a16="http://schemas.microsoft.com/office/drawing/2014/main" id="{106E4FDB-5A46-4F48-8C8F-887A99668FBB}"/>
+                <a16:creationId xmlns:a16="http://schemas.microsoft.com/office/drawing/2014/main" id="{0FD10546-0326-4D6E-82EF-CADBA32C528C}"/>
               </a:ext>
             </a:extLst>
           </p:cNvPr>
@@ -5914,7 +5914,7 @@
           <p:cNvPr id="41" name="loop-result">
             <a:extLst xmlns:a="http://schemas.openxmlformats.org/drawingml/2006/main">
               <a:ext uri="{FF2B5EF4-FFF2-40B4-BE49-F238E27FC236}">
-                <a16:creationId xmlns:a16="http://schemas.microsoft.com/office/drawing/2014/main" id="{4199F23C-3BBE-40CB-B8AB-9FDEC043E258}"/>
+                <a16:creationId xmlns:a16="http://schemas.microsoft.com/office/drawing/2014/main" id="{48453A52-3F26-43AF-BDEC-92399F37BFF4}"/>
               </a:ext>
             </a:extLst>
           </p:cNvPr>
@@ -5962,7 +5962,7 @@
     </p:spTree>
     <p:extLst>
       <p:ext uri="{BB962C8B-B14F-4D97-AF65-F5344CB8AC3E}">
-        <p14:creationId xmlns:p14="http://schemas.microsoft.com/office/powerpoint/2010/main" val="1008414837"/>
+        <p14:creationId xmlns:p14="http://schemas.microsoft.com/office/powerpoint/2010/main" val="252197258"/>
       </p:ext>
     </p:extLst>
   </p:cSld>
@@ -5993,7 +5993,7 @@
           <p:cNvPr id="16" name="section-5">
             <a:extLst xmlns:a="http://schemas.openxmlformats.org/drawingml/2006/main">
               <a:ext uri="{FF2B5EF4-FFF2-40B4-BE49-F238E27FC236}">
-                <a16:creationId xmlns:a16="http://schemas.microsoft.com/office/drawing/2014/main" id="{D6A7C937-E0AE-4E24-8BF6-E3F2EFB3F36B}"/>
+                <a16:creationId xmlns:a16="http://schemas.microsoft.com/office/drawing/2014/main" id="{2BD6497E-89C5-4319-8AC6-611C2C6B950D}"/>
               </a:ext>
             </a:extLst>
           </p:cNvPr>
@@ -6043,7 +6043,7 @@
           <p:cNvPr id="2" name="page-5">
             <a:extLst xmlns:a="http://schemas.openxmlformats.org/drawingml/2006/main">
               <a:ext uri="{FF2B5EF4-FFF2-40B4-BE49-F238E27FC236}">
-                <a16:creationId xmlns:a16="http://schemas.microsoft.com/office/drawing/2014/main" id="{73BCE469-9293-49F9-B901-3C30E7C14026}"/>
+                <a16:creationId xmlns:a16="http://schemas.microsoft.com/office/drawing/2014/main" id="{64BC4DFB-E00C-4191-B523-0CAB28DBC0D1}"/>
               </a:ext>
             </a:extLst>
           </p:cNvPr>
@@ -6093,7 +6093,7 @@
           <p:cNvPr id="3" name="rule-48-66">
             <a:extLst xmlns:a="http://schemas.openxmlformats.org/drawingml/2006/main">
               <a:ext uri="{FF2B5EF4-FFF2-40B4-BE49-F238E27FC236}">
-                <a16:creationId xmlns:a16="http://schemas.microsoft.com/office/drawing/2014/main" id="{34E6F6F9-A353-4465-B15D-F7CAB53ED3A5}"/>
+                <a16:creationId xmlns:a16="http://schemas.microsoft.com/office/drawing/2014/main" id="{AC03248E-B3A9-4D40-9556-2DA4DA674D2E}"/>
               </a:ext>
             </a:extLst>
           </p:cNvPr>
@@ -6121,10 +6121,10 @@
       </p:sp>
       <p:sp>
         <p:nvSpPr>
-          <p:cNvPr id="4" name="title-The Coach is a real multi-turn conversation.">
-            <a:extLst xmlns:a="http://schemas.openxmlformats.org/drawingml/2006/main">
-              <a:ext uri="{FF2B5EF4-FFF2-40B4-BE49-F238E27FC236}">
-                <a16:creationId xmlns:a16="http://schemas.microsoft.com/office/drawing/2014/main" id="{58C42D70-B350-4AB5-B4E3-9CDBD7AD5E34}"/>
+          <p:cNvPr id="4" name="title-The Coach gives one step, then waits.">
+            <a:extLst xmlns:a="http://schemas.openxmlformats.org/drawingml/2006/main">
+              <a:ext uri="{FF2B5EF4-FFF2-40B4-BE49-F238E27FC236}">
+                <a16:creationId xmlns:a16="http://schemas.microsoft.com/office/drawing/2014/main" id="{6ACEF70B-57B1-43DC-8EA1-10AA33361B1A}"/>
               </a:ext>
             </a:extLst>
           </p:cNvPr>
@@ -6164,17 +6164,17 @@
                   <a:srgbClr val="141C22"/>
                 </a:solidFill>
               </a:rPr>
-              <a:t>The Coach is a real multi-turn conversation.</a:t>
-            </a:r>
-          </a:p>
-        </p:txBody>
-      </p:sp>
-      <p:sp>
-        <p:nvSpPr>
-          <p:cNvPr id="5" name="subtitle-The Coach is a real multi-turn conversation.">
-            <a:extLst xmlns:a="http://schemas.openxmlformats.org/drawingml/2006/main">
-              <a:ext uri="{FF2B5EF4-FFF2-40B4-BE49-F238E27FC236}">
-                <a16:creationId xmlns:a16="http://schemas.microsoft.com/office/drawing/2014/main" id="{8BD3A010-2F8A-4C3C-9815-5DB4EA1C3A42}"/>
+              <a:t>The Coach gives one step, then waits.</a:t>
+            </a:r>
+          </a:p>
+        </p:txBody>
+      </p:sp>
+      <p:sp>
+        <p:nvSpPr>
+          <p:cNvPr id="5" name="subtitle-The Coach gives one step, then waits.">
+            <a:extLst xmlns:a="http://schemas.openxmlformats.org/drawingml/2006/main">
+              <a:ext uri="{FF2B5EF4-FFF2-40B4-BE49-F238E27FC236}">
+                <a16:creationId xmlns:a16="http://schemas.microsoft.com/office/drawing/2014/main" id="{9D5B4C67-7F0D-494B-A363-542111335C6A}"/>
               </a:ext>
             </a:extLst>
           </p:cNvPr>
@@ -6214,7 +6214,7 @@
                   <a:srgbClr val="647078"/>
                 </a:solidFill>
               </a:rPr>
-              <a:t>Students can ask a question, challenge the answer, request a plan, and act on the next steps without leaving the assignment.</a:t>
+              <a:t>Students can start, continue, get unstuck, or test an idea without receiving a generic plan or a finished answer.</a:t>
             </a:r>
           </a:p>
         </p:txBody>
@@ -6224,7 +6224,7 @@
           <p:cNvPr id="6" name="coach-screen-frame">
             <a:extLst xmlns:a="http://schemas.openxmlformats.org/drawingml/2006/main">
               <a:ext uri="{FF2B5EF4-FFF2-40B4-BE49-F238E27FC236}">
-                <a16:creationId xmlns:a16="http://schemas.microsoft.com/office/drawing/2014/main" id="{A799AC5B-9B38-44A8-B2C8-FDCF013F893B}"/>
+                <a16:creationId xmlns:a16="http://schemas.microsoft.com/office/drawing/2014/main" id="{9722DD13-DEB5-4F3A-9786-D16D3EC289EF}"/>
               </a:ext>
             </a:extLst>
           </p:cNvPr>
@@ -6263,8 +6263,8 @@
           <p:nvPr/>
         </p:nvPicPr>
         <p:blipFill>
-          <a:blip xmlns:r="http://schemas.openxmlformats.org/officeDocument/2006/relationships" xmlns:a="http://schemas.openxmlformats.org/drawingml/2006/main" r:embed="R130e1cb852ff49fe"/>
-          <a:srcRect xmlns:a="http://schemas.openxmlformats.org/drawingml/2006/main" l="0" t="10874" r="0" b="10874"/>
+          <a:blip xmlns:r="http://schemas.openxmlformats.org/officeDocument/2006/relationships" xmlns:a="http://schemas.openxmlformats.org/drawingml/2006/main" r:embed="Rd8fc379cbe1d4275"/>
+          <a:srcRect xmlns:a="http://schemas.openxmlformats.org/drawingml/2006/main" l="0" t="6527" r="0" b="6527"/>
           <a:stretch xmlns:a="http://schemas.openxmlformats.org/drawingml/2006/main">
             <a:fillRect l="0" t="0" r="0" b="0"/>
           </a:stretch>
@@ -6286,7 +6286,7 @@
           <p:cNvPr id="8" name="coach-label-0">
             <a:extLst xmlns:a="http://schemas.openxmlformats.org/drawingml/2006/main">
               <a:ext uri="{FF2B5EF4-FFF2-40B4-BE49-F238E27FC236}">
-                <a16:creationId xmlns:a16="http://schemas.microsoft.com/office/drawing/2014/main" id="{C3A4ACB2-2B8D-4B45-9780-691F2C568C46}"/>
+                <a16:creationId xmlns:a16="http://schemas.microsoft.com/office/drawing/2014/main" id="{24DC8C12-00E9-4615-9F38-CFCDA5A7E0B0}"/>
               </a:ext>
             </a:extLst>
           </p:cNvPr>
@@ -6326,7 +6326,7 @@
                   <a:srgbClr val="2F7D74"/>
                 </a:solidFill>
               </a:rPr>
-              <a:t>FOLLOW UP</a:t>
+              <a:t>ADAPT</a:t>
             </a:r>
           </a:p>
         </p:txBody>
@@ -6336,7 +6336,7 @@
           <p:cNvPr id="9" name="coach-copy-0">
             <a:extLst xmlns:a="http://schemas.openxmlformats.org/drawingml/2006/main">
               <a:ext uri="{FF2B5EF4-FFF2-40B4-BE49-F238E27FC236}">
-                <a16:creationId xmlns:a16="http://schemas.microsoft.com/office/drawing/2014/main" id="{4B027DEB-DA4A-4829-AEDB-50C568344DC6}"/>
+                <a16:creationId xmlns:a16="http://schemas.microsoft.com/office/drawing/2014/main" id="{331608B7-E49F-4967-9BFC-D85100AC2509}"/>
               </a:ext>
             </a:extLst>
           </p:cNvPr>
@@ -6376,7 +6376,7 @@
                   <a:srgbClr val="647078"/>
                 </a:solidFill>
               </a:rPr>
-              <a:t>Conversation history stays scoped to the selected course and assignment.</a:t>
+              <a:t>The next action advances, shrinks, or changes after each student response.</a:t>
             </a:r>
           </a:p>
         </p:txBody>
@@ -6386,7 +6386,7 @@
           <p:cNvPr id="10" name="rule-830-362">
             <a:extLst xmlns:a="http://schemas.openxmlformats.org/drawingml/2006/main">
               <a:ext uri="{FF2B5EF4-FFF2-40B4-BE49-F238E27FC236}">
-                <a16:creationId xmlns:a16="http://schemas.microsoft.com/office/drawing/2014/main" id="{B7D045E8-20F3-440F-AC9F-2494F1A9D7E4}"/>
+                <a16:creationId xmlns:a16="http://schemas.microsoft.com/office/drawing/2014/main" id="{3E18A0A7-A61A-4B00-BABC-5808042C7ECC}"/>
               </a:ext>
             </a:extLst>
           </p:cNvPr>
@@ -6417,7 +6417,7 @@
           <p:cNvPr id="11" name="coach-label-1">
             <a:extLst xmlns:a="http://schemas.openxmlformats.org/drawingml/2006/main">
               <a:ext uri="{FF2B5EF4-FFF2-40B4-BE49-F238E27FC236}">
-                <a16:creationId xmlns:a16="http://schemas.microsoft.com/office/drawing/2014/main" id="{CBA2F5A4-0E3F-4B42-9AEB-58DC73FABCF9}"/>
+                <a16:creationId xmlns:a16="http://schemas.microsoft.com/office/drawing/2014/main" id="{D9456207-5AB8-4D8C-A95E-157A644FF271}"/>
               </a:ext>
             </a:extLst>
           </p:cNvPr>
@@ -6467,7 +6467,7 @@
           <p:cNvPr id="12" name="coach-copy-1">
             <a:extLst xmlns:a="http://schemas.openxmlformats.org/drawingml/2006/main">
               <a:ext uri="{FF2B5EF4-FFF2-40B4-BE49-F238E27FC236}">
-                <a16:creationId xmlns:a16="http://schemas.microsoft.com/office/drawing/2014/main" id="{00A1B16B-E3FC-4CB9-A36C-3D83321EA2EF}"/>
+                <a16:creationId xmlns:a16="http://schemas.microsoft.com/office/drawing/2014/main" id="{FE33BE70-2258-4484-AA30-3CD2BBB82D31}"/>
               </a:ext>
             </a:extLst>
           </p:cNvPr>
@@ -6507,7 +6507,7 @@
                   <a:srgbClr val="647078"/>
                 </a:solidFill>
               </a:rPr>
-              <a:t>Evidence chips point back to exact due dates, requirements, and rubric text.</a:t>
+              <a:t>Evidence chips point back to exact dates, requirements, and rubric text.</a:t>
             </a:r>
           </a:p>
         </p:txBody>
@@ -6517,7 +6517,7 @@
           <p:cNvPr id="13" name="rule-830-486">
             <a:extLst xmlns:a="http://schemas.openxmlformats.org/drawingml/2006/main">
               <a:ext uri="{FF2B5EF4-FFF2-40B4-BE49-F238E27FC236}">
-                <a16:creationId xmlns:a16="http://schemas.microsoft.com/office/drawing/2014/main" id="{83B0F387-77A3-46B5-9EA7-C9B5E0163009}"/>
+                <a16:creationId xmlns:a16="http://schemas.microsoft.com/office/drawing/2014/main" id="{31FBC723-687F-4CB5-B777-2CA984365CBE}"/>
               </a:ext>
             </a:extLst>
           </p:cNvPr>
@@ -6548,7 +6548,7 @@
           <p:cNvPr id="14" name="coach-label-2">
             <a:extLst xmlns:a="http://schemas.openxmlformats.org/drawingml/2006/main">
               <a:ext uri="{FF2B5EF4-FFF2-40B4-BE49-F238E27FC236}">
-                <a16:creationId xmlns:a16="http://schemas.microsoft.com/office/drawing/2014/main" id="{993E66AE-10AA-4265-B8AB-AE761AF0CC42}"/>
+                <a16:creationId xmlns:a16="http://schemas.microsoft.com/office/drawing/2014/main" id="{6CA07AA3-C2EF-4A99-A28C-13A293370101}"/>
               </a:ext>
             </a:extLst>
           </p:cNvPr>
@@ -6588,7 +6588,7 @@
                   <a:srgbClr val="2F7D74"/>
                 </a:solidFill>
               </a:rPr>
-              <a:t>ACT</a:t>
+              <a:t>OWN</a:t>
             </a:r>
           </a:p>
         </p:txBody>
@@ -6598,7 +6598,7 @@
           <p:cNvPr id="15" name="coach-copy-2">
             <a:extLst xmlns:a="http://schemas.openxmlformats.org/drawingml/2006/main">
               <a:ext uri="{FF2B5EF4-FFF2-40B4-BE49-F238E27FC236}">
-                <a16:creationId xmlns:a16="http://schemas.microsoft.com/office/drawing/2014/main" id="{FBF6161E-81B5-4FFD-BDF2-89AA11C7DCE7}"/>
+                <a16:creationId xmlns:a16="http://schemas.microsoft.com/office/drawing/2014/main" id="{5596E9B4-4D0D-45A1-854D-1F15F3043CF1}"/>
               </a:ext>
             </a:extLst>
           </p:cNvPr>
@@ -6638,7 +6638,7 @@
                   <a:srgbClr val="647078"/>
                 </a:solidFill>
               </a:rPr>
-              <a:t>Any suggested next step can be added directly to the assignment checklist.</a:t>
+              <a:t>The Coach protects student authorship and adds its step to the checklist.</a:t>
             </a:r>
           </a:p>
         </p:txBody>
@@ -6646,7 +6646,7 @@
     </p:spTree>
     <p:extLst>
       <p:ext uri="{BB962C8B-B14F-4D97-AF65-F5344CB8AC3E}">
-        <p14:creationId xmlns:p14="http://schemas.microsoft.com/office/powerpoint/2010/main" val="671696357"/>
+        <p14:creationId xmlns:p14="http://schemas.microsoft.com/office/powerpoint/2010/main" val="583151108"/>
       </p:ext>
     </p:extLst>
   </p:cSld>
@@ -6677,7 +6677,7 @@
           <p:cNvPr id="24" name="section-6">
             <a:extLst xmlns:a="http://schemas.openxmlformats.org/drawingml/2006/main">
               <a:ext uri="{FF2B5EF4-FFF2-40B4-BE49-F238E27FC236}">
-                <a16:creationId xmlns:a16="http://schemas.microsoft.com/office/drawing/2014/main" id="{8CB14444-5BF1-458E-B6CA-D714B48815F4}"/>
+                <a16:creationId xmlns:a16="http://schemas.microsoft.com/office/drawing/2014/main" id="{D5E6DB6D-610D-4B61-92D9-655A26706C0A}"/>
               </a:ext>
             </a:extLst>
           </p:cNvPr>
@@ -6727,7 +6727,7 @@
           <p:cNvPr id="2" name="page-6">
             <a:extLst xmlns:a="http://schemas.openxmlformats.org/drawingml/2006/main">
               <a:ext uri="{FF2B5EF4-FFF2-40B4-BE49-F238E27FC236}">
-                <a16:creationId xmlns:a16="http://schemas.microsoft.com/office/drawing/2014/main" id="{B2FD077E-3200-4466-8D6E-C362B7AA7890}"/>
+                <a16:creationId xmlns:a16="http://schemas.microsoft.com/office/drawing/2014/main" id="{0A886CD6-40C5-4F0F-9C44-C355AEA2794C}"/>
               </a:ext>
             </a:extLst>
           </p:cNvPr>
@@ -6777,7 +6777,7 @@
           <p:cNvPr id="3" name="rule-48-66">
             <a:extLst xmlns:a="http://schemas.openxmlformats.org/drawingml/2006/main">
               <a:ext uri="{FF2B5EF4-FFF2-40B4-BE49-F238E27FC236}">
-                <a16:creationId xmlns:a16="http://schemas.microsoft.com/office/drawing/2014/main" id="{85D89935-F0FE-4CE4-81D2-26CA31D1C6A9}"/>
+                <a16:creationId xmlns:a16="http://schemas.microsoft.com/office/drawing/2014/main" id="{C9E0563E-9D71-4954-B499-DE0A1E7EB04F}"/>
               </a:ext>
             </a:extLst>
           </p:cNvPr>
@@ -6808,7 +6808,7 @@
           <p:cNvPr id="4" name="title-Planning and final checks stay connected.">
             <a:extLst xmlns:a="http://schemas.openxmlformats.org/drawingml/2006/main">
               <a:ext uri="{FF2B5EF4-FFF2-40B4-BE49-F238E27FC236}">
-                <a16:creationId xmlns:a16="http://schemas.microsoft.com/office/drawing/2014/main" id="{BA1F6E61-854E-4D9F-8DF0-A550F6C97912}"/>
+                <a16:creationId xmlns:a16="http://schemas.microsoft.com/office/drawing/2014/main" id="{CA988B5F-F07E-43E1-8331-865911240121}"/>
               </a:ext>
             </a:extLst>
           </p:cNvPr>
@@ -6858,7 +6858,7 @@
           <p:cNvPr id="5" name="subtitle-Planning and final checks stay connected.">
             <a:extLst xmlns:a="http://schemas.openxmlformats.org/drawingml/2006/main">
               <a:ext uri="{FF2B5EF4-FFF2-40B4-BE49-F238E27FC236}">
-                <a16:creationId xmlns:a16="http://schemas.microsoft.com/office/drawing/2014/main" id="{46DC5EAE-2D0B-4AE2-856D-CD2D96C26E59}"/>
+                <a16:creationId xmlns:a16="http://schemas.microsoft.com/office/drawing/2014/main" id="{6262FF70-41F6-4B23-8666-3DEF25BD36E6}"/>
               </a:ext>
             </a:extLst>
           </p:cNvPr>
@@ -6908,7 +6908,7 @@
           <p:cNvPr id="6" name="daily-tag-0">
             <a:extLst xmlns:a="http://schemas.openxmlformats.org/drawingml/2006/main">
               <a:ext uri="{FF2B5EF4-FFF2-40B4-BE49-F238E27FC236}">
-                <a16:creationId xmlns:a16="http://schemas.microsoft.com/office/drawing/2014/main" id="{37611E16-AEB6-4943-A058-FA00F8A21D83}"/>
+                <a16:creationId xmlns:a16="http://schemas.microsoft.com/office/drawing/2014/main" id="{94F42046-EE15-4C12-9A2A-C4BB74F40307}"/>
               </a:ext>
             </a:extLst>
           </p:cNvPr>
@@ -6958,7 +6958,7 @@
           <p:cNvPr id="7" name="daily-title-0">
             <a:extLst xmlns:a="http://schemas.openxmlformats.org/drawingml/2006/main">
               <a:ext uri="{FF2B5EF4-FFF2-40B4-BE49-F238E27FC236}">
-                <a16:creationId xmlns:a16="http://schemas.microsoft.com/office/drawing/2014/main" id="{7EE8623E-F6BC-475E-960D-94A471563D7E}"/>
+                <a16:creationId xmlns:a16="http://schemas.microsoft.com/office/drawing/2014/main" id="{A9275F16-5280-4CF3-BC6C-2ED603FD6C7C}"/>
               </a:ext>
             </a:extLst>
           </p:cNvPr>
@@ -7008,7 +7008,7 @@
           <p:cNvPr id="8" name="daily-copy-0">
             <a:extLst xmlns:a="http://schemas.openxmlformats.org/drawingml/2006/main">
               <a:ext uri="{FF2B5EF4-FFF2-40B4-BE49-F238E27FC236}">
-                <a16:creationId xmlns:a16="http://schemas.microsoft.com/office/drawing/2014/main" id="{DBBC28C7-FC68-4F58-A9AA-853A95AFFCE4}"/>
+                <a16:creationId xmlns:a16="http://schemas.microsoft.com/office/drawing/2014/main" id="{837C8ABD-8515-4176-AB98-9E8B9BA2A31E}"/>
               </a:ext>
             </a:extLst>
           </p:cNvPr>
@@ -7058,7 +7058,7 @@
           <p:cNvPr id="9" name="rule-58-310">
             <a:extLst xmlns:a="http://schemas.openxmlformats.org/drawingml/2006/main">
               <a:ext uri="{FF2B5EF4-FFF2-40B4-BE49-F238E27FC236}">
-                <a16:creationId xmlns:a16="http://schemas.microsoft.com/office/drawing/2014/main" id="{C85943EB-66D2-4B7E-A49A-DC499099AB5D}"/>
+                <a16:creationId xmlns:a16="http://schemas.microsoft.com/office/drawing/2014/main" id="{2BD447D1-56AF-4F7C-A267-0B1CF3D4FCFE}"/>
               </a:ext>
             </a:extLst>
           </p:cNvPr>
@@ -7089,7 +7089,7 @@
           <p:cNvPr id="10" name="daily-tag-1">
             <a:extLst xmlns:a="http://schemas.openxmlformats.org/drawingml/2006/main">
               <a:ext uri="{FF2B5EF4-FFF2-40B4-BE49-F238E27FC236}">
-                <a16:creationId xmlns:a16="http://schemas.microsoft.com/office/drawing/2014/main" id="{CE66F96E-AE5B-4C51-9D48-57AA6AA7759F}"/>
+                <a16:creationId xmlns:a16="http://schemas.microsoft.com/office/drawing/2014/main" id="{5150FD79-84E1-4485-9488-611A17873C3A}"/>
               </a:ext>
             </a:extLst>
           </p:cNvPr>
@@ -7139,7 +7139,7 @@
           <p:cNvPr id="11" name="daily-title-1">
             <a:extLst xmlns:a="http://schemas.openxmlformats.org/drawingml/2006/main">
               <a:ext uri="{FF2B5EF4-FFF2-40B4-BE49-F238E27FC236}">
-                <a16:creationId xmlns:a16="http://schemas.microsoft.com/office/drawing/2014/main" id="{C45B8E18-85A2-43A0-8DC4-45E8EF0AB5D8}"/>
+                <a16:creationId xmlns:a16="http://schemas.microsoft.com/office/drawing/2014/main" id="{A9069B83-2697-4C36-9AC0-795F55EA1921}"/>
               </a:ext>
             </a:extLst>
           </p:cNvPr>
@@ -7189,7 +7189,7 @@
           <p:cNvPr id="12" name="daily-copy-1">
             <a:extLst xmlns:a="http://schemas.openxmlformats.org/drawingml/2006/main">
               <a:ext uri="{FF2B5EF4-FFF2-40B4-BE49-F238E27FC236}">
-                <a16:creationId xmlns:a16="http://schemas.microsoft.com/office/drawing/2014/main" id="{2FD19688-DE13-48C8-903A-30F6C96F9082}"/>
+                <a16:creationId xmlns:a16="http://schemas.microsoft.com/office/drawing/2014/main" id="{3CA171E6-D644-4847-BF7B-6F835CC214F0}"/>
               </a:ext>
             </a:extLst>
           </p:cNvPr>
@@ -7239,7 +7239,7 @@
           <p:cNvPr id="13" name="rule-58-402">
             <a:extLst xmlns:a="http://schemas.openxmlformats.org/drawingml/2006/main">
               <a:ext uri="{FF2B5EF4-FFF2-40B4-BE49-F238E27FC236}">
-                <a16:creationId xmlns:a16="http://schemas.microsoft.com/office/drawing/2014/main" id="{F01DEEDF-28C9-4A54-96D5-BB504025E232}"/>
+                <a16:creationId xmlns:a16="http://schemas.microsoft.com/office/drawing/2014/main" id="{12978677-03E4-4B68-94FD-26B88927A784}"/>
               </a:ext>
             </a:extLst>
           </p:cNvPr>
@@ -7270,7 +7270,7 @@
           <p:cNvPr id="14" name="daily-tag-2">
             <a:extLst xmlns:a="http://schemas.openxmlformats.org/drawingml/2006/main">
               <a:ext uri="{FF2B5EF4-FFF2-40B4-BE49-F238E27FC236}">
-                <a16:creationId xmlns:a16="http://schemas.microsoft.com/office/drawing/2014/main" id="{77A2A086-1FB7-449C-872C-ADE12A9916BD}"/>
+                <a16:creationId xmlns:a16="http://schemas.microsoft.com/office/drawing/2014/main" id="{3D4D4DE0-769C-46D3-9F5E-6C167B8D8F39}"/>
               </a:ext>
             </a:extLst>
           </p:cNvPr>
@@ -7320,7 +7320,7 @@
           <p:cNvPr id="15" name="daily-title-2">
             <a:extLst xmlns:a="http://schemas.openxmlformats.org/drawingml/2006/main">
               <a:ext uri="{FF2B5EF4-FFF2-40B4-BE49-F238E27FC236}">
-                <a16:creationId xmlns:a16="http://schemas.microsoft.com/office/drawing/2014/main" id="{14575ABB-FEFD-4078-8917-C04E5FCF514B}"/>
+                <a16:creationId xmlns:a16="http://schemas.microsoft.com/office/drawing/2014/main" id="{1500CB96-6A2E-4B0E-A363-B8952344904C}"/>
               </a:ext>
             </a:extLst>
           </p:cNvPr>
@@ -7370,7 +7370,7 @@
           <p:cNvPr id="16" name="daily-copy-2">
             <a:extLst xmlns:a="http://schemas.openxmlformats.org/drawingml/2006/main">
               <a:ext uri="{FF2B5EF4-FFF2-40B4-BE49-F238E27FC236}">
-                <a16:creationId xmlns:a16="http://schemas.microsoft.com/office/drawing/2014/main" id="{1F2A2494-FCF3-45B1-8746-38D06E30EA9C}"/>
+                <a16:creationId xmlns:a16="http://schemas.microsoft.com/office/drawing/2014/main" id="{98B1E9F6-9A71-4DE8-8F1A-A87D831F077B}"/>
               </a:ext>
             </a:extLst>
           </p:cNvPr>
@@ -7420,7 +7420,7 @@
           <p:cNvPr id="17" name="rule-58-494">
             <a:extLst xmlns:a="http://schemas.openxmlformats.org/drawingml/2006/main">
               <a:ext uri="{FF2B5EF4-FFF2-40B4-BE49-F238E27FC236}">
-                <a16:creationId xmlns:a16="http://schemas.microsoft.com/office/drawing/2014/main" id="{10EF45ED-858B-4012-AFFC-80F3E6513432}"/>
+                <a16:creationId xmlns:a16="http://schemas.microsoft.com/office/drawing/2014/main" id="{9B53DEDF-8A24-484B-BDC1-888FF4238D52}"/>
               </a:ext>
             </a:extLst>
           </p:cNvPr>
@@ -7451,7 +7451,7 @@
           <p:cNvPr id="18" name="daily-tag-3">
             <a:extLst xmlns:a="http://schemas.openxmlformats.org/drawingml/2006/main">
               <a:ext uri="{FF2B5EF4-FFF2-40B4-BE49-F238E27FC236}">
-                <a16:creationId xmlns:a16="http://schemas.microsoft.com/office/drawing/2014/main" id="{69EB1374-7B73-4A50-8901-085E51C968B3}"/>
+                <a16:creationId xmlns:a16="http://schemas.microsoft.com/office/drawing/2014/main" id="{B5E4310B-0BA4-4C07-9525-3448C187B1C5}"/>
               </a:ext>
             </a:extLst>
           </p:cNvPr>
@@ -7501,7 +7501,7 @@
           <p:cNvPr id="19" name="daily-title-3">
             <a:extLst xmlns:a="http://schemas.openxmlformats.org/drawingml/2006/main">
               <a:ext uri="{FF2B5EF4-FFF2-40B4-BE49-F238E27FC236}">
-                <a16:creationId xmlns:a16="http://schemas.microsoft.com/office/drawing/2014/main" id="{8F8A82F8-C305-41AD-BDC1-040DA59AEC54}"/>
+                <a16:creationId xmlns:a16="http://schemas.microsoft.com/office/drawing/2014/main" id="{A3BEB680-0E42-4FCD-8E23-D21F43EB5DE7}"/>
               </a:ext>
             </a:extLst>
           </p:cNvPr>
@@ -7541,7 +7541,7 @@
                   <a:srgbClr val="141C22"/>
                 </a:solidFill>
               </a:rPr>
-              <a:t>Read-only sync</a:t>
+              <a:t>Keyless import</a:t>
             </a:r>
           </a:p>
         </p:txBody>
@@ -7551,7 +7551,7 @@
           <p:cNvPr id="20" name="daily-copy-3">
             <a:extLst xmlns:a="http://schemas.openxmlformats.org/drawingml/2006/main">
               <a:ext uri="{FF2B5EF4-FFF2-40B4-BE49-F238E27FC236}">
-                <a16:creationId xmlns:a16="http://schemas.microsoft.com/office/drawing/2014/main" id="{729FC4B9-3FED-41EB-A1A5-6ADCBFD787F9}"/>
+                <a16:creationId xmlns:a16="http://schemas.microsoft.com/office/drawing/2014/main" id="{8958CB10-3273-41E9-AF14-2DAA45B26519}"/>
               </a:ext>
             </a:extLst>
           </p:cNvPr>
@@ -7591,7 +7591,7 @@
                   <a:srgbClr val="647078"/>
                 </a:solidFill>
               </a:rPr>
-              <a:t>Imports active courses, syllabus content, assignments, dates, points, and submission state through scoped OAuth.</a:t>
+              <a:t>Imports deadlines through a Canvas calendar feed or captures the current Canvas page with the Companion. School OAuth remains optional.</a:t>
             </a:r>
           </a:p>
         </p:txBody>
@@ -7601,7 +7601,7 @@
           <p:cNvPr id="21" name="rule-58-586">
             <a:extLst xmlns:a="http://schemas.openxmlformats.org/drawingml/2006/main">
               <a:ext uri="{FF2B5EF4-FFF2-40B4-BE49-F238E27FC236}">
-                <a16:creationId xmlns:a16="http://schemas.microsoft.com/office/drawing/2014/main" id="{0FAE2545-B6C2-4DDE-8987-F0A982183738}"/>
+                <a16:creationId xmlns:a16="http://schemas.microsoft.com/office/drawing/2014/main" id="{438C2BA3-DF19-4FA7-A12C-A346F9AE1F8E}"/>
               </a:ext>
             </a:extLst>
           </p:cNvPr>
@@ -7632,7 +7632,7 @@
           <p:cNvPr id="22" name="canvas-boundary">
             <a:extLst xmlns:a="http://schemas.openxmlformats.org/drawingml/2006/main">
               <a:ext uri="{FF2B5EF4-FFF2-40B4-BE49-F238E27FC236}">
-                <a16:creationId xmlns:a16="http://schemas.microsoft.com/office/drawing/2014/main" id="{5CF05043-3533-4735-855D-17077080F380}"/>
+                <a16:creationId xmlns:a16="http://schemas.microsoft.com/office/drawing/2014/main" id="{6D3A10A9-A24A-4277-AAE7-50DD763E26E4}"/>
               </a:ext>
             </a:extLst>
           </p:cNvPr>
@@ -7667,7 +7667,7 @@
           <p:cNvPr id="23" name="canvas-boundary-text">
             <a:extLst xmlns:a="http://schemas.openxmlformats.org/drawingml/2006/main">
               <a:ext uri="{FF2B5EF4-FFF2-40B4-BE49-F238E27FC236}">
-                <a16:creationId xmlns:a16="http://schemas.microsoft.com/office/drawing/2014/main" id="{91D6FAE6-435D-49C1-B3C0-9C2987B552F1}"/>
+                <a16:creationId xmlns:a16="http://schemas.microsoft.com/office/drawing/2014/main" id="{C8F5B0CE-27A4-4E1D-AA4A-89D2A1657E0B}"/>
               </a:ext>
             </a:extLst>
           </p:cNvPr>
@@ -7707,7 +7707,7 @@
                   <a:srgbClr val="725E16"/>
                 </a:solidFill>
               </a:rPr>
-              <a:t>Canvas connection code is complete; live school access still requires an administrator-approved Developer Key.</a:t>
+              <a:t>No Developer Key required: use the Canvas calendar feed or the click-to-capture Companion.</a:t>
             </a:r>
           </a:p>
         </p:txBody>
@@ -7715,7 +7715,7 @@
     </p:spTree>
     <p:extLst>
       <p:ext uri="{BB962C8B-B14F-4D97-AF65-F5344CB8AC3E}">
-        <p14:creationId xmlns:p14="http://schemas.microsoft.com/office/powerpoint/2010/main" val="1166567586"/>
+        <p14:creationId xmlns:p14="http://schemas.microsoft.com/office/powerpoint/2010/main" val="1025784097"/>
       </p:ext>
     </p:extLst>
   </p:cSld>
@@ -7746,7 +7746,7 @@
           <p:cNvPr id="29" name="section-7">
             <a:extLst xmlns:a="http://schemas.openxmlformats.org/drawingml/2006/main">
               <a:ext uri="{FF2B5EF4-FFF2-40B4-BE49-F238E27FC236}">
-                <a16:creationId xmlns:a16="http://schemas.microsoft.com/office/drawing/2014/main" id="{C468B355-C192-4019-966B-A58974286522}"/>
+                <a16:creationId xmlns:a16="http://schemas.microsoft.com/office/drawing/2014/main" id="{8315674E-89F8-4193-A1AA-F6DD7822B864}"/>
               </a:ext>
             </a:extLst>
           </p:cNvPr>
@@ -7796,7 +7796,7 @@
           <p:cNvPr id="2" name="page-7">
             <a:extLst xmlns:a="http://schemas.openxmlformats.org/drawingml/2006/main">
               <a:ext uri="{FF2B5EF4-FFF2-40B4-BE49-F238E27FC236}">
-                <a16:creationId xmlns:a16="http://schemas.microsoft.com/office/drawing/2014/main" id="{C801743E-CFC8-429F-B054-C95FDDB464EE}"/>
+                <a16:creationId xmlns:a16="http://schemas.microsoft.com/office/drawing/2014/main" id="{59F77726-37BF-4381-A2DF-E1E4C7DEEF13}"/>
               </a:ext>
             </a:extLst>
           </p:cNvPr>
@@ -7846,7 +7846,7 @@
           <p:cNvPr id="3" name="rule-48-66">
             <a:extLst xmlns:a="http://schemas.openxmlformats.org/drawingml/2006/main">
               <a:ext uri="{FF2B5EF4-FFF2-40B4-BE49-F238E27FC236}">
-                <a16:creationId xmlns:a16="http://schemas.microsoft.com/office/drawing/2014/main" id="{F1A3D063-83B7-4C7D-8693-1B06D1CC0547}"/>
+                <a16:creationId xmlns:a16="http://schemas.microsoft.com/office/drawing/2014/main" id="{EF1170A8-C574-4A88-B5DF-A4AECFC54971}"/>
               </a:ext>
             </a:extLst>
           </p:cNvPr>
@@ -7877,7 +7877,7 @@
           <p:cNvPr id="4" name="title-Live AI stays bounded to the selected work.">
             <a:extLst xmlns:a="http://schemas.openxmlformats.org/drawingml/2006/main">
               <a:ext uri="{FF2B5EF4-FFF2-40B4-BE49-F238E27FC236}">
-                <a16:creationId xmlns:a16="http://schemas.microsoft.com/office/drawing/2014/main" id="{F0E7A196-7DBB-4F97-BC28-F42A4E6E6DB8}"/>
+                <a16:creationId xmlns:a16="http://schemas.microsoft.com/office/drawing/2014/main" id="{5F28C0FF-6A23-407D-9296-DB89BFF23036}"/>
               </a:ext>
             </a:extLst>
           </p:cNvPr>
@@ -7927,7 +7927,7 @@
           <p:cNvPr id="5" name="subtitle-Live AI stays bounded to the selected work.">
             <a:extLst xmlns:a="http://schemas.openxmlformats.org/drawingml/2006/main">
               <a:ext uri="{FF2B5EF4-FFF2-40B4-BE49-F238E27FC236}">
-                <a16:creationId xmlns:a16="http://schemas.microsoft.com/office/drawing/2014/main" id="{97B110A3-DF50-4779-9BCD-C4BB5DE1013D}"/>
+                <a16:creationId xmlns:a16="http://schemas.microsoft.com/office/drawing/2014/main" id="{2059F11D-7386-4DF3-B8AC-F14538CA1EC7}"/>
               </a:ext>
             </a:extLst>
           </p:cNvPr>
@@ -7977,7 +7977,7 @@
           <p:cNvPr id="6" name="architecture-node-0">
             <a:extLst xmlns:a="http://schemas.openxmlformats.org/drawingml/2006/main">
               <a:ext uri="{FF2B5EF4-FFF2-40B4-BE49-F238E27FC236}">
-                <a16:creationId xmlns:a16="http://schemas.microsoft.com/office/drawing/2014/main" id="{B17E8E83-07E2-407C-9AD4-A60902A697A9}"/>
+                <a16:creationId xmlns:a16="http://schemas.microsoft.com/office/drawing/2014/main" id="{A1EA4E3D-58AC-4DDB-B0DF-27BF45809C5A}"/>
               </a:ext>
             </a:extLst>
           </p:cNvPr>
@@ -8012,7 +8012,7 @@
           <p:cNvPr id="7" name="architecture-index-0">
             <a:extLst xmlns:a="http://schemas.openxmlformats.org/drawingml/2006/main">
               <a:ext uri="{FF2B5EF4-FFF2-40B4-BE49-F238E27FC236}">
-                <a16:creationId xmlns:a16="http://schemas.microsoft.com/office/drawing/2014/main" id="{CD318C1D-3E3D-4EED-924A-B7D1A93753F0}"/>
+                <a16:creationId xmlns:a16="http://schemas.microsoft.com/office/drawing/2014/main" id="{0B380102-5DE3-4919-8FDF-3E54F30D9A63}"/>
               </a:ext>
             </a:extLst>
           </p:cNvPr>
@@ -8062,7 +8062,7 @@
           <p:cNvPr id="8" name="architecture-title-0">
             <a:extLst xmlns:a="http://schemas.openxmlformats.org/drawingml/2006/main">
               <a:ext uri="{FF2B5EF4-FFF2-40B4-BE49-F238E27FC236}">
-                <a16:creationId xmlns:a16="http://schemas.microsoft.com/office/drawing/2014/main" id="{AE0044F3-22B0-4674-8955-5E8C114F8933}"/>
+                <a16:creationId xmlns:a16="http://schemas.microsoft.com/office/drawing/2014/main" id="{9F56E78F-EC8A-4FA8-9447-46BDFFA5CDD0}"/>
               </a:ext>
             </a:extLst>
           </p:cNvPr>
@@ -8112,7 +8112,7 @@
           <p:cNvPr id="9" name="architecture-body-0">
             <a:extLst xmlns:a="http://schemas.openxmlformats.org/drawingml/2006/main">
               <a:ext uri="{FF2B5EF4-FFF2-40B4-BE49-F238E27FC236}">
-                <a16:creationId xmlns:a16="http://schemas.microsoft.com/office/drawing/2014/main" id="{4F794061-DF01-4156-AB06-BC654BDEE6CC}"/>
+                <a16:creationId xmlns:a16="http://schemas.microsoft.com/office/drawing/2014/main" id="{583C7794-ADAE-44FB-B4A0-2099879B7340}"/>
               </a:ext>
             </a:extLst>
           </p:cNvPr>
@@ -8162,7 +8162,7 @@
           <p:cNvPr id="10" name="rule-298-378">
             <a:extLst xmlns:a="http://schemas.openxmlformats.org/drawingml/2006/main">
               <a:ext uri="{FF2B5EF4-FFF2-40B4-BE49-F238E27FC236}">
-                <a16:creationId xmlns:a16="http://schemas.microsoft.com/office/drawing/2014/main" id="{5F370885-20C4-4D1F-B153-882142BD3AEA}"/>
+                <a16:creationId xmlns:a16="http://schemas.microsoft.com/office/drawing/2014/main" id="{74E3EFB4-922C-4C75-AD10-4AE892ACB2AD}"/>
               </a:ext>
             </a:extLst>
           </p:cNvPr>
@@ -8193,7 +8193,7 @@
           <p:cNvPr id="11" name="architecture-arrow-0">
             <a:extLst xmlns:a="http://schemas.openxmlformats.org/drawingml/2006/main">
               <a:ext uri="{FF2B5EF4-FFF2-40B4-BE49-F238E27FC236}">
-                <a16:creationId xmlns:a16="http://schemas.microsoft.com/office/drawing/2014/main" id="{DDD27821-77F3-4194-BF0D-225E8C96E3DE}"/>
+                <a16:creationId xmlns:a16="http://schemas.microsoft.com/office/drawing/2014/main" id="{DCA5FA50-14D8-4EE7-BF43-AC1EF2ABDAC7}"/>
               </a:ext>
             </a:extLst>
           </p:cNvPr>
@@ -8226,7 +8226,7 @@
           <p:cNvPr id="12" name="architecture-node-1">
             <a:extLst xmlns:a="http://schemas.openxmlformats.org/drawingml/2006/main">
               <a:ext uri="{FF2B5EF4-FFF2-40B4-BE49-F238E27FC236}">
-                <a16:creationId xmlns:a16="http://schemas.microsoft.com/office/drawing/2014/main" id="{54E99595-8C0F-4760-8E27-7837EEE25CA7}"/>
+                <a16:creationId xmlns:a16="http://schemas.microsoft.com/office/drawing/2014/main" id="{8BB80893-39A5-4763-85D3-6608074C14F3}"/>
               </a:ext>
             </a:extLst>
           </p:cNvPr>
@@ -8261,7 +8261,7 @@
           <p:cNvPr id="13" name="architecture-index-1">
             <a:extLst xmlns:a="http://schemas.openxmlformats.org/drawingml/2006/main">
               <a:ext uri="{FF2B5EF4-FFF2-40B4-BE49-F238E27FC236}">
-                <a16:creationId xmlns:a16="http://schemas.microsoft.com/office/drawing/2014/main" id="{FE631B5B-ED58-45D9-8884-8892AB6B73FD}"/>
+                <a16:creationId xmlns:a16="http://schemas.microsoft.com/office/drawing/2014/main" id="{895ABCB2-7F0B-470A-9E52-6BED17243AAA}"/>
               </a:ext>
             </a:extLst>
           </p:cNvPr>
@@ -8311,7 +8311,7 @@
           <p:cNvPr id="14" name="architecture-title-1">
             <a:extLst xmlns:a="http://schemas.openxmlformats.org/drawingml/2006/main">
               <a:ext uri="{FF2B5EF4-FFF2-40B4-BE49-F238E27FC236}">
-                <a16:creationId xmlns:a16="http://schemas.microsoft.com/office/drawing/2014/main" id="{54C8B05D-CE3C-44BC-9F14-64129E1D581E}"/>
+                <a16:creationId xmlns:a16="http://schemas.microsoft.com/office/drawing/2014/main" id="{E3089BB5-4F8D-4319-B7CD-E9F2EB0C1F9A}"/>
               </a:ext>
             </a:extLst>
           </p:cNvPr>
@@ -8361,7 +8361,7 @@
           <p:cNvPr id="15" name="architecture-body-1">
             <a:extLst xmlns:a="http://schemas.openxmlformats.org/drawingml/2006/main">
               <a:ext uri="{FF2B5EF4-FFF2-40B4-BE49-F238E27FC236}">
-                <a16:creationId xmlns:a16="http://schemas.microsoft.com/office/drawing/2014/main" id="{7B82EC68-95F3-4AA0-A8AA-21AF5A10A9B5}"/>
+                <a16:creationId xmlns:a16="http://schemas.microsoft.com/office/drawing/2014/main" id="{93BAB925-A343-4215-BC39-ABEEE4114B16}"/>
               </a:ext>
             </a:extLst>
           </p:cNvPr>
@@ -8411,7 +8411,7 @@
           <p:cNvPr id="16" name="rule-600-378">
             <a:extLst xmlns:a="http://schemas.openxmlformats.org/drawingml/2006/main">
               <a:ext uri="{FF2B5EF4-FFF2-40B4-BE49-F238E27FC236}">
-                <a16:creationId xmlns:a16="http://schemas.microsoft.com/office/drawing/2014/main" id="{BF1C4EB2-AA3A-4D5C-9216-CB0B31AEE5E7}"/>
+                <a16:creationId xmlns:a16="http://schemas.microsoft.com/office/drawing/2014/main" id="{98141546-235B-4A16-B195-097FC696DF97}"/>
               </a:ext>
             </a:extLst>
           </p:cNvPr>
@@ -8442,7 +8442,7 @@
           <p:cNvPr id="17" name="architecture-arrow-1">
             <a:extLst xmlns:a="http://schemas.openxmlformats.org/drawingml/2006/main">
               <a:ext uri="{FF2B5EF4-FFF2-40B4-BE49-F238E27FC236}">
-                <a16:creationId xmlns:a16="http://schemas.microsoft.com/office/drawing/2014/main" id="{58027C6D-708E-492F-BC5D-239BF42BC51C}"/>
+                <a16:creationId xmlns:a16="http://schemas.microsoft.com/office/drawing/2014/main" id="{97CD7A88-8A15-468A-AEAA-CEC767A7AA61}"/>
               </a:ext>
             </a:extLst>
           </p:cNvPr>
@@ -8475,7 +8475,7 @@
           <p:cNvPr id="18" name="architecture-node-2">
             <a:extLst xmlns:a="http://schemas.openxmlformats.org/drawingml/2006/main">
               <a:ext uri="{FF2B5EF4-FFF2-40B4-BE49-F238E27FC236}">
-                <a16:creationId xmlns:a16="http://schemas.microsoft.com/office/drawing/2014/main" id="{75B9CB6F-EC73-4C27-9D30-EAC361731C43}"/>
+                <a16:creationId xmlns:a16="http://schemas.microsoft.com/office/drawing/2014/main" id="{4A471F4F-6C61-456B-98F2-4CA679704E2F}"/>
               </a:ext>
             </a:extLst>
           </p:cNvPr>
@@ -8510,7 +8510,7 @@
           <p:cNvPr id="19" name="architecture-index-2">
             <a:extLst xmlns:a="http://schemas.openxmlformats.org/drawingml/2006/main">
               <a:ext uri="{FF2B5EF4-FFF2-40B4-BE49-F238E27FC236}">
-                <a16:creationId xmlns:a16="http://schemas.microsoft.com/office/drawing/2014/main" id="{AFB6C743-1816-4E9D-A48F-8E49C389933D}"/>
+                <a16:creationId xmlns:a16="http://schemas.microsoft.com/office/drawing/2014/main" id="{BBAF524F-7D58-4A56-9E11-E09C65009ABB}"/>
               </a:ext>
             </a:extLst>
           </p:cNvPr>
@@ -8560,7 +8560,7 @@
           <p:cNvPr id="20" name="architecture-title-2">
             <a:extLst xmlns:a="http://schemas.openxmlformats.org/drawingml/2006/main">
               <a:ext uri="{FF2B5EF4-FFF2-40B4-BE49-F238E27FC236}">
-                <a16:creationId xmlns:a16="http://schemas.microsoft.com/office/drawing/2014/main" id="{B9F734A9-6641-42D9-B7B1-02C706ABFCED}"/>
+                <a16:creationId xmlns:a16="http://schemas.microsoft.com/office/drawing/2014/main" id="{1AE58874-010F-41E8-8BDF-9C7177AEE0E5}"/>
               </a:ext>
             </a:extLst>
           </p:cNvPr>
@@ -8610,7 +8610,7 @@
           <p:cNvPr id="21" name="architecture-body-2">
             <a:extLst xmlns:a="http://schemas.openxmlformats.org/drawingml/2006/main">
               <a:ext uri="{FF2B5EF4-FFF2-40B4-BE49-F238E27FC236}">
-                <a16:creationId xmlns:a16="http://schemas.microsoft.com/office/drawing/2014/main" id="{13A18EE4-C23A-4ECF-BBB2-B908B59A7082}"/>
+                <a16:creationId xmlns:a16="http://schemas.microsoft.com/office/drawing/2014/main" id="{D8F5AB91-51AF-43C9-9A78-F6212D128272}"/>
               </a:ext>
             </a:extLst>
           </p:cNvPr>
@@ -8660,7 +8660,7 @@
           <p:cNvPr id="22" name="rule-902-378">
             <a:extLst xmlns:a="http://schemas.openxmlformats.org/drawingml/2006/main">
               <a:ext uri="{FF2B5EF4-FFF2-40B4-BE49-F238E27FC236}">
-                <a16:creationId xmlns:a16="http://schemas.microsoft.com/office/drawing/2014/main" id="{0D2CF3E9-FC34-4FB1-A275-4A304009A259}"/>
+                <a16:creationId xmlns:a16="http://schemas.microsoft.com/office/drawing/2014/main" id="{4C2366E1-888C-4274-8EEC-F062320E91E6}"/>
               </a:ext>
             </a:extLst>
           </p:cNvPr>
@@ -8691,7 +8691,7 @@
           <p:cNvPr id="23" name="architecture-arrow-2">
             <a:extLst xmlns:a="http://schemas.openxmlformats.org/drawingml/2006/main">
               <a:ext uri="{FF2B5EF4-FFF2-40B4-BE49-F238E27FC236}">
-                <a16:creationId xmlns:a16="http://schemas.microsoft.com/office/drawing/2014/main" id="{D0F06623-40BA-4309-A2CF-35CF46593005}"/>
+                <a16:creationId xmlns:a16="http://schemas.microsoft.com/office/drawing/2014/main" id="{F424522D-01AF-4EEE-9BC2-E2EE0669A4E8}"/>
               </a:ext>
             </a:extLst>
           </p:cNvPr>
@@ -8724,7 +8724,7 @@
           <p:cNvPr id="24" name="architecture-node-3">
             <a:extLst xmlns:a="http://schemas.openxmlformats.org/drawingml/2006/main">
               <a:ext uri="{FF2B5EF4-FFF2-40B4-BE49-F238E27FC236}">
-                <a16:creationId xmlns:a16="http://schemas.microsoft.com/office/drawing/2014/main" id="{AEE8860B-873B-4E55-AB4B-BDCC9EB19EA4}"/>
+                <a16:creationId xmlns:a16="http://schemas.microsoft.com/office/drawing/2014/main" id="{D615ABD1-D416-4A5D-A141-0F92FCC557B2}"/>
               </a:ext>
             </a:extLst>
           </p:cNvPr>
@@ -8759,7 +8759,7 @@
           <p:cNvPr id="25" name="architecture-index-3">
             <a:extLst xmlns:a="http://schemas.openxmlformats.org/drawingml/2006/main">
               <a:ext uri="{FF2B5EF4-FFF2-40B4-BE49-F238E27FC236}">
-                <a16:creationId xmlns:a16="http://schemas.microsoft.com/office/drawing/2014/main" id="{7A3F9F1C-76E2-4B49-AFD7-297748A6BA0A}"/>
+                <a16:creationId xmlns:a16="http://schemas.microsoft.com/office/drawing/2014/main" id="{671584D3-F256-4071-9FC3-7F2EB679AB43}"/>
               </a:ext>
             </a:extLst>
           </p:cNvPr>
@@ -8809,7 +8809,7 @@
           <p:cNvPr id="26" name="architecture-title-3">
             <a:extLst xmlns:a="http://schemas.openxmlformats.org/drawingml/2006/main">
               <a:ext uri="{FF2B5EF4-FFF2-40B4-BE49-F238E27FC236}">
-                <a16:creationId xmlns:a16="http://schemas.microsoft.com/office/drawing/2014/main" id="{D4822DAF-C9CB-4844-A2DA-8F97C0CA3FEC}"/>
+                <a16:creationId xmlns:a16="http://schemas.microsoft.com/office/drawing/2014/main" id="{7B0C7905-3C9B-414A-9DAC-0736F62CD6BF}"/>
               </a:ext>
             </a:extLst>
           </p:cNvPr>
@@ -8859,7 +8859,7 @@
           <p:cNvPr id="27" name="architecture-body-3">
             <a:extLst xmlns:a="http://schemas.openxmlformats.org/drawingml/2006/main">
               <a:ext uri="{FF2B5EF4-FFF2-40B4-BE49-F238E27FC236}">
-                <a16:creationId xmlns:a16="http://schemas.microsoft.com/office/drawing/2014/main" id="{4BBF4285-10FD-4F11-B72B-B63457F6D3D8}"/>
+                <a16:creationId xmlns:a16="http://schemas.microsoft.com/office/drawing/2014/main" id="{50B4877D-079A-4789-88E8-7DCD833432DC}"/>
               </a:ext>
             </a:extLst>
           </p:cNvPr>
@@ -8899,7 +8899,7 @@
                   <a:srgbClr val="647078"/>
                 </a:solidFill>
               </a:rPr>
-              <a:t>Live answer, citations, next steps</a:t>
+              <a:t>Live answer, citations, one next step</a:t>
             </a:r>
           </a:p>
         </p:txBody>
@@ -8909,7 +8909,7 @@
           <p:cNvPr id="28" name="architecture-caption">
             <a:extLst xmlns:a="http://schemas.openxmlformats.org/drawingml/2006/main">
               <a:ext uri="{FF2B5EF4-FFF2-40B4-BE49-F238E27FC236}">
-                <a16:creationId xmlns:a16="http://schemas.microsoft.com/office/drawing/2014/main" id="{ED4BFA69-C0CF-43E3-A46B-640A62BD7524}"/>
+                <a16:creationId xmlns:a16="http://schemas.microsoft.com/office/drawing/2014/main" id="{EA06B4E2-A24C-46CA-89CC-41BA0EF8CCBB}"/>
               </a:ext>
             </a:extLst>
           </p:cNvPr>
@@ -8949,7 +8949,7 @@
                   <a:srgbClr val="647078"/>
                 </a:solidFill>
               </a:rPr>
-              <a:t>No secret is stored in client code. Invalid citations are removed, missing evidence is surfaced, and the Coach is instructed not to write an entire assessed submission.</a:t>
+              <a:t>No secret is stored in client code. Invalid citations are removed, malformed model output is repaired, and complete assessed submissions are redirected into student-owned reasoning.</a:t>
             </a:r>
           </a:p>
         </p:txBody>
@@ -8957,7 +8957,7 @@
     </p:spTree>
     <p:extLst>
       <p:ext uri="{BB962C8B-B14F-4D97-AF65-F5344CB8AC3E}">
-        <p14:creationId xmlns:p14="http://schemas.microsoft.com/office/powerpoint/2010/main" val="193680843"/>
+        <p14:creationId xmlns:p14="http://schemas.microsoft.com/office/powerpoint/2010/main" val="672966255"/>
       </p:ext>
     </p:extLst>
   </p:cSld>
@@ -8988,7 +8988,7 @@
           <p:cNvPr id="20" name="section-8">
             <a:extLst xmlns:a="http://schemas.openxmlformats.org/drawingml/2006/main">
               <a:ext uri="{FF2B5EF4-FFF2-40B4-BE49-F238E27FC236}">
-                <a16:creationId xmlns:a16="http://schemas.microsoft.com/office/drawing/2014/main" id="{0C403526-8641-4E4F-BAF4-7FC86D2358E9}"/>
+                <a16:creationId xmlns:a16="http://schemas.microsoft.com/office/drawing/2014/main" id="{71B3A6E5-7BAC-4E6D-B7B8-D2FA51AA89DE}"/>
               </a:ext>
             </a:extLst>
           </p:cNvPr>
@@ -9038,7 +9038,7 @@
           <p:cNvPr id="2" name="page-8">
             <a:extLst xmlns:a="http://schemas.openxmlformats.org/drawingml/2006/main">
               <a:ext uri="{FF2B5EF4-FFF2-40B4-BE49-F238E27FC236}">
-                <a16:creationId xmlns:a16="http://schemas.microsoft.com/office/drawing/2014/main" id="{F9D48018-2B5B-4063-AEAF-3B1434986730}"/>
+                <a16:creationId xmlns:a16="http://schemas.microsoft.com/office/drawing/2014/main" id="{B1C57CAA-6DFB-4E61-8452-8F5B8940B64D}"/>
               </a:ext>
             </a:extLst>
           </p:cNvPr>
@@ -9088,7 +9088,7 @@
           <p:cNvPr id="3" name="rule-48-66">
             <a:extLst xmlns:a="http://schemas.openxmlformats.org/drawingml/2006/main">
               <a:ext uri="{FF2B5EF4-FFF2-40B4-BE49-F238E27FC236}">
-                <a16:creationId xmlns:a16="http://schemas.microsoft.com/office/drawing/2014/main" id="{5E12379A-0A6E-4295-BC88-66D33B56574A}"/>
+                <a16:creationId xmlns:a16="http://schemas.microsoft.com/office/drawing/2014/main" id="{7C508C06-EF27-4B57-AB0F-B61B55489CF8}"/>
               </a:ext>
             </a:extLst>
           </p:cNvPr>
@@ -9119,7 +9119,7 @@
           <p:cNvPr id="4" name="title-The complete workflow is tested, not staged.">
             <a:extLst xmlns:a="http://schemas.openxmlformats.org/drawingml/2006/main">
               <a:ext uri="{FF2B5EF4-FFF2-40B4-BE49-F238E27FC236}">
-                <a16:creationId xmlns:a16="http://schemas.microsoft.com/office/drawing/2014/main" id="{3AEEECA4-2908-4920-B5F7-87D9A8CCFA31}"/>
+                <a16:creationId xmlns:a16="http://schemas.microsoft.com/office/drawing/2014/main" id="{D0E73F49-5097-41B0-B876-4C1F51FF9581}"/>
               </a:ext>
             </a:extLst>
           </p:cNvPr>
@@ -9169,7 +9169,7 @@
           <p:cNvPr id="5" name="subtitle-The complete workflow is tested, not staged.">
             <a:extLst xmlns:a="http://schemas.openxmlformats.org/drawingml/2006/main">
               <a:ext uri="{FF2B5EF4-FFF2-40B4-BE49-F238E27FC236}">
-                <a16:creationId xmlns:a16="http://schemas.microsoft.com/office/drawing/2014/main" id="{D0ABF649-755A-4221-B6AF-CA07DCF7835C}"/>
+                <a16:creationId xmlns:a16="http://schemas.microsoft.com/office/drawing/2014/main" id="{3F8379D5-9315-4A26-B438-C0DEE9C5A121}"/>
               </a:ext>
             </a:extLst>
           </p:cNvPr>
@@ -9219,7 +9219,7 @@
           <p:cNvPr id="6" name="stat-0">
             <a:extLst xmlns:a="http://schemas.openxmlformats.org/drawingml/2006/main">
               <a:ext uri="{FF2B5EF4-FFF2-40B4-BE49-F238E27FC236}">
-                <a16:creationId xmlns:a16="http://schemas.microsoft.com/office/drawing/2014/main" id="{0ADB01AF-1FA1-41B3-BD87-706B30E6E141}"/>
+                <a16:creationId xmlns:a16="http://schemas.microsoft.com/office/drawing/2014/main" id="{635D6D1D-4870-4DEB-8C76-A69DD77FF82B}"/>
               </a:ext>
             </a:extLst>
           </p:cNvPr>
@@ -9254,7 +9254,7 @@
           <p:cNvPr id="7" name="stat-value-0">
             <a:extLst xmlns:a="http://schemas.openxmlformats.org/drawingml/2006/main">
               <a:ext uri="{FF2B5EF4-FFF2-40B4-BE49-F238E27FC236}">
-                <a16:creationId xmlns:a16="http://schemas.microsoft.com/office/drawing/2014/main" id="{06CCFD77-9165-47D7-8D8B-C98FFCC7857B}"/>
+                <a16:creationId xmlns:a16="http://schemas.microsoft.com/office/drawing/2014/main" id="{7BABFBD6-5CDC-443A-B9C3-F11D4D5C6DBE}"/>
               </a:ext>
             </a:extLst>
           </p:cNvPr>
@@ -9294,7 +9294,7 @@
                   <a:srgbClr val="2F7D74"/>
                 </a:solidFill>
               </a:rPr>
-              <a:t>326</a:t>
+              <a:t>365</a:t>
             </a:r>
           </a:p>
         </p:txBody>
@@ -9304,7 +9304,7 @@
           <p:cNvPr id="8" name="stat-label-0">
             <a:extLst xmlns:a="http://schemas.openxmlformats.org/drawingml/2006/main">
               <a:ext uri="{FF2B5EF4-FFF2-40B4-BE49-F238E27FC236}">
-                <a16:creationId xmlns:a16="http://schemas.microsoft.com/office/drawing/2014/main" id="{987E85F9-CB6A-4A3C-907A-978957A61213}"/>
+                <a16:creationId xmlns:a16="http://schemas.microsoft.com/office/drawing/2014/main" id="{B9C345DE-0190-4026-AD6C-ACAC0186AD44}"/>
               </a:ext>
             </a:extLst>
           </p:cNvPr>
@@ -9354,7 +9354,7 @@
           <p:cNvPr id="9" name="stat-1">
             <a:extLst xmlns:a="http://schemas.openxmlformats.org/drawingml/2006/main">
               <a:ext uri="{FF2B5EF4-FFF2-40B4-BE49-F238E27FC236}">
-                <a16:creationId xmlns:a16="http://schemas.microsoft.com/office/drawing/2014/main" id="{2FF9B683-B955-4E0D-A003-5932F853C809}"/>
+                <a16:creationId xmlns:a16="http://schemas.microsoft.com/office/drawing/2014/main" id="{32A9A9D9-A5F7-40ED-83C6-83DC27405A97}"/>
               </a:ext>
             </a:extLst>
           </p:cNvPr>
@@ -9389,7 +9389,7 @@
           <p:cNvPr id="10" name="stat-value-1">
             <a:extLst xmlns:a="http://schemas.openxmlformats.org/drawingml/2006/main">
               <a:ext uri="{FF2B5EF4-FFF2-40B4-BE49-F238E27FC236}">
-                <a16:creationId xmlns:a16="http://schemas.microsoft.com/office/drawing/2014/main" id="{F16180B9-CCF5-402E-93E8-EC4D1D5B4DA1}"/>
+                <a16:creationId xmlns:a16="http://schemas.microsoft.com/office/drawing/2014/main" id="{EBD01141-C19A-45C9-8B27-1107AAF455C6}"/>
               </a:ext>
             </a:extLst>
           </p:cNvPr>
@@ -9439,7 +9439,7 @@
           <p:cNvPr id="11" name="stat-label-1">
             <a:extLst xmlns:a="http://schemas.openxmlformats.org/drawingml/2006/main">
               <a:ext uri="{FF2B5EF4-FFF2-40B4-BE49-F238E27FC236}">
-                <a16:creationId xmlns:a16="http://schemas.microsoft.com/office/drawing/2014/main" id="{8E85B373-F2AD-4AE9-A9EF-F60B89F55FB3}"/>
+                <a16:creationId xmlns:a16="http://schemas.microsoft.com/office/drawing/2014/main" id="{11CCCF22-8891-4427-9380-285EA4B208A8}"/>
               </a:ext>
             </a:extLst>
           </p:cNvPr>
@@ -9489,7 +9489,7 @@
           <p:cNvPr id="12" name="stat-2">
             <a:extLst xmlns:a="http://schemas.openxmlformats.org/drawingml/2006/main">
               <a:ext uri="{FF2B5EF4-FFF2-40B4-BE49-F238E27FC236}">
-                <a16:creationId xmlns:a16="http://schemas.microsoft.com/office/drawing/2014/main" id="{2A0ACFB2-600D-4FFE-9A4E-74A5B6B16B31}"/>
+                <a16:creationId xmlns:a16="http://schemas.microsoft.com/office/drawing/2014/main" id="{1EE4C8CD-96F7-488A-A1A0-C4BB5569DEEC}"/>
               </a:ext>
             </a:extLst>
           </p:cNvPr>
@@ -9524,7 +9524,7 @@
           <p:cNvPr id="13" name="stat-value-2">
             <a:extLst xmlns:a="http://schemas.openxmlformats.org/drawingml/2006/main">
               <a:ext uri="{FF2B5EF4-FFF2-40B4-BE49-F238E27FC236}">
-                <a16:creationId xmlns:a16="http://schemas.microsoft.com/office/drawing/2014/main" id="{9B820956-53BD-483C-9A20-D5EE1D516A4F}"/>
+                <a16:creationId xmlns:a16="http://schemas.microsoft.com/office/drawing/2014/main" id="{9C944DEB-9EFA-4BAF-A23E-025FC7E26E13}"/>
               </a:ext>
             </a:extLst>
           </p:cNvPr>
@@ -9574,7 +9574,7 @@
           <p:cNvPr id="14" name="stat-label-2">
             <a:extLst xmlns:a="http://schemas.openxmlformats.org/drawingml/2006/main">
               <a:ext uri="{FF2B5EF4-FFF2-40B4-BE49-F238E27FC236}">
-                <a16:creationId xmlns:a16="http://schemas.microsoft.com/office/drawing/2014/main" id="{FD3470DF-5378-43DA-B62B-A3186509D531}"/>
+                <a16:creationId xmlns:a16="http://schemas.microsoft.com/office/drawing/2014/main" id="{643DA8E6-1FCC-4113-9AD4-1EB4C2F3E80C}"/>
               </a:ext>
             </a:extLst>
           </p:cNvPr>
@@ -9624,7 +9624,7 @@
           <p:cNvPr id="15" name="validation-list">
             <a:extLst xmlns:a="http://schemas.openxmlformats.org/drawingml/2006/main">
               <a:ext uri="{FF2B5EF4-FFF2-40B4-BE49-F238E27FC236}">
-                <a16:creationId xmlns:a16="http://schemas.microsoft.com/office/drawing/2014/main" id="{278B415E-746D-4A22-B247-B4C93553A357}"/>
+                <a16:creationId xmlns:a16="http://schemas.microsoft.com/office/drawing/2014/main" id="{43103C09-0CA6-4211-9F65-23A65588837B}"/>
               </a:ext>
             </a:extLst>
           </p:cNvPr>
@@ -9754,7 +9754,7 @@
                   <a:srgbClr val="647078"/>
                 </a:solidFill>
               </a:rPr>
-              <a:t>Coach -&gt; two live turns, citations, readable three-day plan</a:t>
+              <a:t>Coach -&gt; start, advance, stuck support, and authorship protection</a:t>
             </a:r>
           </a:p>
         </p:txBody>
@@ -9764,7 +9764,7 @@
           <p:cNvPr id="16" name="mobile-frame">
             <a:extLst xmlns:a="http://schemas.openxmlformats.org/drawingml/2006/main">
               <a:ext uri="{FF2B5EF4-FFF2-40B4-BE49-F238E27FC236}">
-                <a16:creationId xmlns:a16="http://schemas.microsoft.com/office/drawing/2014/main" id="{E1328298-75A7-4BD7-BD45-E3DEACD3E12E}"/>
+                <a16:creationId xmlns:a16="http://schemas.microsoft.com/office/drawing/2014/main" id="{2583CC95-0AE3-4989-B474-2808F0B3D9AF}"/>
               </a:ext>
             </a:extLst>
           </p:cNvPr>
@@ -9803,7 +9803,7 @@
           <p:nvPr/>
         </p:nvPicPr>
         <p:blipFill>
-          <a:blip xmlns:r="http://schemas.openxmlformats.org/officeDocument/2006/relationships" xmlns:a="http://schemas.openxmlformats.org/drawingml/2006/main" r:embed="R268bedd48886494c"/>
+          <a:blip xmlns:r="http://schemas.openxmlformats.org/officeDocument/2006/relationships" xmlns:a="http://schemas.openxmlformats.org/drawingml/2006/main" r:embed="R17a03dad87fc4bb9"/>
           <a:srcRect xmlns:a="http://schemas.openxmlformats.org/drawingml/2006/main" l="0" t="12718" r="0" b="12718"/>
           <a:stretch xmlns:a="http://schemas.openxmlformats.org/drawingml/2006/main">
             <a:fillRect l="0" t="0" r="0" b="0"/>
@@ -9826,7 +9826,7 @@
           <p:cNvPr id="18" name="label-Mobile QA-1090">
             <a:extLst xmlns:a="http://schemas.openxmlformats.org/drawingml/2006/main">
               <a:ext uri="{FF2B5EF4-FFF2-40B4-BE49-F238E27FC236}">
-                <a16:creationId xmlns:a16="http://schemas.microsoft.com/office/drawing/2014/main" id="{8B564D44-2CD8-4AB7-80F0-94139379E013}"/>
+                <a16:creationId xmlns:a16="http://schemas.microsoft.com/office/drawing/2014/main" id="{BA9F4130-48BF-4A85-87C9-35F845C71C30}"/>
               </a:ext>
             </a:extLst>
           </p:cNvPr>
@@ -9882,7 +9882,7 @@
           <p:cNvPr id="19" name="mobile-callout">
             <a:extLst xmlns:a="http://schemas.openxmlformats.org/drawingml/2006/main">
               <a:ext uri="{FF2B5EF4-FFF2-40B4-BE49-F238E27FC236}">
-                <a16:creationId xmlns:a16="http://schemas.microsoft.com/office/drawing/2014/main" id="{C69A67BA-FC0C-4726-8CEB-79C2AD331BA3}"/>
+                <a16:creationId xmlns:a16="http://schemas.microsoft.com/office/drawing/2014/main" id="{8500F3CF-6E77-48D3-AF1F-0E2D55B3DAF5}"/>
               </a:ext>
             </a:extLst>
           </p:cNvPr>
@@ -9922,7 +9922,7 @@
                   <a:srgbClr val="647078"/>
                 </a:solidFill>
               </a:rPr>
-              <a:t>No page or transcript overflow at 390 x 844. The live Coach returned citations and a readable multi-day plan.</a:t>
+              <a:t>No horizontal overflow at 390 x 844. The current step and all three feedback actions remain usable.</a:t>
             </a:r>
           </a:p>
         </p:txBody>
@@ -9930,7 +9930,7 @@
     </p:spTree>
     <p:extLst>
       <p:ext uri="{BB962C8B-B14F-4D97-AF65-F5344CB8AC3E}">
-        <p14:creationId xmlns:p14="http://schemas.microsoft.com/office/powerpoint/2010/main" val="413168301"/>
+        <p14:creationId xmlns:p14="http://schemas.microsoft.com/office/powerpoint/2010/main" val="1763832311"/>
       </p:ext>
     </p:extLst>
   </p:cSld>
@@ -9961,7 +9961,7 @@
           <p:cNvPr id="8" name="close-kicker">
             <a:extLst xmlns:a="http://schemas.openxmlformats.org/drawingml/2006/main">
               <a:ext uri="{FF2B5EF4-FFF2-40B4-BE49-F238E27FC236}">
-                <a16:creationId xmlns:a16="http://schemas.microsoft.com/office/drawing/2014/main" id="{92425B85-D062-48E3-8DC7-30D37986F8DA}"/>
+                <a16:creationId xmlns:a16="http://schemas.microsoft.com/office/drawing/2014/main" id="{55EC7C1E-DD68-4410-AAF4-5FBF54C4ACD1}"/>
               </a:ext>
             </a:extLst>
           </p:cNvPr>
@@ -10011,7 +10011,7 @@
           <p:cNvPr id="2" name="close-title">
             <a:extLst xmlns:a="http://schemas.openxmlformats.org/drawingml/2006/main">
               <a:ext uri="{FF2B5EF4-FFF2-40B4-BE49-F238E27FC236}">
-                <a16:creationId xmlns:a16="http://schemas.microsoft.com/office/drawing/2014/main" id="{86DF85D7-08E6-40D8-935A-492FA828867B}"/>
+                <a16:creationId xmlns:a16="http://schemas.microsoft.com/office/drawing/2014/main" id="{8B874115-8008-44E9-9C2D-3C293BD16077}"/>
               </a:ext>
             </a:extLst>
           </p:cNvPr>
@@ -10095,7 +10095,7 @@
           <p:cNvPr id="3" name="close-body">
             <a:extLst xmlns:a="http://schemas.openxmlformats.org/drawingml/2006/main">
               <a:ext uri="{FF2B5EF4-FFF2-40B4-BE49-F238E27FC236}">
-                <a16:creationId xmlns:a16="http://schemas.microsoft.com/office/drawing/2014/main" id="{3AB467EF-C481-4330-B6D1-515D1A163240}"/>
+                <a16:creationId xmlns:a16="http://schemas.microsoft.com/office/drawing/2014/main" id="{A47E72D2-4FB8-4897-A01E-53E44C3D1A8C}"/>
               </a:ext>
             </a:extLst>
           </p:cNvPr>
@@ -10145,7 +10145,7 @@
           <p:cNvPr id="4" name="close-link">
             <a:extLst xmlns:a="http://schemas.openxmlformats.org/drawingml/2006/main">
               <a:ext uri="{FF2B5EF4-FFF2-40B4-BE49-F238E27FC236}">
-                <a16:creationId xmlns:a16="http://schemas.microsoft.com/office/drawing/2014/main" id="{C97BB3FD-6BFA-43DE-850E-60AA7AC8EECE}"/>
+                <a16:creationId xmlns:a16="http://schemas.microsoft.com/office/drawing/2014/main" id="{C0B08B47-883C-4DB9-91A6-6C84538991CD}"/>
               </a:ext>
             </a:extLst>
           </p:cNvPr>
@@ -10180,7 +10180,7 @@
           <p:cNvPr id="5" name="close-link-label">
             <a:extLst xmlns:a="http://schemas.openxmlformats.org/drawingml/2006/main">
               <a:ext uri="{FF2B5EF4-FFF2-40B4-BE49-F238E27FC236}">
-                <a16:creationId xmlns:a16="http://schemas.microsoft.com/office/drawing/2014/main" id="{D408B31F-975E-496F-B1CC-B472B7D4CA17}"/>
+                <a16:creationId xmlns:a16="http://schemas.microsoft.com/office/drawing/2014/main" id="{5B4946F7-D499-4F9A-8FC5-EB880CA96072}"/>
               </a:ext>
             </a:extLst>
           </p:cNvPr>
@@ -10230,7 +10230,7 @@
           <p:cNvPr id="6" name="close-link-url">
             <a:extLst xmlns:a="http://schemas.openxmlformats.org/drawingml/2006/main">
               <a:ext uri="{FF2B5EF4-FFF2-40B4-BE49-F238E27FC236}">
-                <a16:creationId xmlns:a16="http://schemas.microsoft.com/office/drawing/2014/main" id="{20AF6A1F-F254-4019-93F1-3F23109B7897}"/>
+                <a16:creationId xmlns:a16="http://schemas.microsoft.com/office/drawing/2014/main" id="{AA3BF4E4-8B60-4F0F-942B-9AD073F3DBA3}"/>
               </a:ext>
             </a:extLst>
           </p:cNvPr>
@@ -10297,7 +10297,7 @@
           <p:cNvPr id="7" name="close-note">
             <a:extLst xmlns:a="http://schemas.openxmlformats.org/drawingml/2006/main">
               <a:ext uri="{FF2B5EF4-FFF2-40B4-BE49-F238E27FC236}">
-                <a16:creationId xmlns:a16="http://schemas.microsoft.com/office/drawing/2014/main" id="{6CCCA737-F997-4F5E-8118-6F97D2A1086F}"/>
+                <a16:creationId xmlns:a16="http://schemas.microsoft.com/office/drawing/2014/main" id="{9ECB1B40-74E9-4ECF-9747-87BDBB318C51}"/>
               </a:ext>
             </a:extLst>
           </p:cNvPr>
@@ -10345,7 +10345,7 @@
     </p:spTree>
     <p:extLst>
       <p:ext uri="{BB962C8B-B14F-4D97-AF65-F5344CB8AC3E}">
-        <p14:creationId xmlns:p14="http://schemas.microsoft.com/office/powerpoint/2010/main" val="1348786821"/>
+        <p14:creationId xmlns:p14="http://schemas.microsoft.com/office/powerpoint/2010/main" val="2060588918"/>
       </p:ext>
     </p:extLst>
   </p:cSld>

</xml_diff>